<commit_message>
Add master index and category index formats
Add a structured document management system using color-coded folders and indexed pages.

Included:

Main master index format for tracking all folders
Individual folder index system for multiple categories
Category-wise index pages with laminated sticky notes
Sequential labeling for better navigation
Guidelines for maintaining photocopy counts
Optional enhancements like zigzag tabs and color coding

This system improves document accessibility and reduces the need to manually search through files, making it suitable for both personal and office use.
</commit_message>
<xml_diff>
--- a/Document_Organization/Document_Folder_Formatting.pptx
+++ b/Document_Organization/Document_Folder_Formatting.pptx
@@ -5,7 +5,7 @@
     <p:sldMasterId id="2147483648" r:id="rId1"/>
   </p:sldMasterIdLst>
   <p:notesMasterIdLst>
-    <p:notesMasterId r:id="rId10"/>
+    <p:notesMasterId r:id="rId12"/>
   </p:notesMasterIdLst>
   <p:sldIdLst>
     <p:sldId id="257" r:id="rId2"/>
@@ -14,8 +14,10 @@
     <p:sldId id="256" r:id="rId5"/>
     <p:sldId id="262" r:id="rId6"/>
     <p:sldId id="261" r:id="rId7"/>
-    <p:sldId id="260" r:id="rId8"/>
-    <p:sldId id="259" r:id="rId9"/>
+    <p:sldId id="264" r:id="rId8"/>
+    <p:sldId id="265" r:id="rId9"/>
+    <p:sldId id="260" r:id="rId10"/>
+    <p:sldId id="259" r:id="rId11"/>
   </p:sldIdLst>
   <p:sldSz cx="12192000" cy="6858000"/>
   <p:notesSz cx="6858000" cy="9144000"/>
@@ -1107,10 +1109,10 @@
         <a:p>
           <a:pPr algn="just"/>
           <a:r>
-            <a:rPr lang="en-US"/>
-            <a:t>Also keep an expandable folder (plastic folder with sections) for document verification. Keep required documents in it and take it for DV; once done, keep them back in the files.</a:t>
+            <a:rPr lang="en-US" dirty="0"/>
+            <a:t>Also keep an expandable accordion folder (plastic folder with sections) for document verification. Keep required documents in it and take it for DV; once done, keep them back in the files.</a:t>
           </a:r>
-          <a:endParaRPr lang="en-IN"/>
+          <a:endParaRPr lang="en-IN" dirty="0"/>
         </a:p>
       </dgm:t>
     </dgm:pt>
@@ -1799,10 +1801,10 @@
             <a:buNone/>
           </a:pPr>
           <a:r>
-            <a:rPr lang="en-US" sz="1900" kern="1200"/>
-            <a:t>Also keep an expandable folder (plastic folder with sections) for document verification. Keep required documents in it and take it for DV; once done, keep them back in the files.</a:t>
+            <a:rPr lang="en-US" sz="1900" kern="1200" dirty="0"/>
+            <a:t>Also keep an expandable accordion folder (plastic folder with sections) for document verification. Keep required documents in it and take it for DV; once done, keep them back in the files.</a:t>
           </a:r>
-          <a:endParaRPr lang="en-IN" sz="1900" kern="1200"/>
+          <a:endParaRPr lang="en-IN" sz="1900" kern="1200" dirty="0"/>
         </a:p>
       </dsp:txBody>
       <dsp:txXfrm>
@@ -3123,7 +3125,7 @@
           <a:p>
             <a:fld id="{B8F0210C-1BDD-4952-85C7-BA7C0230B72A}" type="datetimeFigureOut">
               <a:rPr lang="en-IN" smtClean="0"/>
-              <a:t>23-03-2026</a:t>
+              <a:t>02-04-2026</a:t>
             </a:fld>
             <a:endParaRPr lang="en-IN"/>
           </a:p>
@@ -3627,7 +3629,7 @@
           <a:p>
             <a:fld id="{A544FFC6-13CD-4522-9B98-D20659D3626D}" type="datetimeFigureOut">
               <a:rPr lang="en-IN" smtClean="0"/>
-              <a:t>23-03-2026</a:t>
+              <a:t>02-04-2026</a:t>
             </a:fld>
             <a:endParaRPr lang="en-IN"/>
           </a:p>
@@ -3827,7 +3829,7 @@
           <a:p>
             <a:fld id="{A544FFC6-13CD-4522-9B98-D20659D3626D}" type="datetimeFigureOut">
               <a:rPr lang="en-IN" smtClean="0"/>
-              <a:t>23-03-2026</a:t>
+              <a:t>02-04-2026</a:t>
             </a:fld>
             <a:endParaRPr lang="en-IN"/>
           </a:p>
@@ -4037,7 +4039,7 @@
           <a:p>
             <a:fld id="{A544FFC6-13CD-4522-9B98-D20659D3626D}" type="datetimeFigureOut">
               <a:rPr lang="en-IN" smtClean="0"/>
-              <a:t>23-03-2026</a:t>
+              <a:t>02-04-2026</a:t>
             </a:fld>
             <a:endParaRPr lang="en-IN"/>
           </a:p>
@@ -4237,7 +4239,7 @@
           <a:p>
             <a:fld id="{A544FFC6-13CD-4522-9B98-D20659D3626D}" type="datetimeFigureOut">
               <a:rPr lang="en-IN" smtClean="0"/>
-              <a:t>23-03-2026</a:t>
+              <a:t>02-04-2026</a:t>
             </a:fld>
             <a:endParaRPr lang="en-IN"/>
           </a:p>
@@ -4513,7 +4515,7 @@
           <a:p>
             <a:fld id="{A544FFC6-13CD-4522-9B98-D20659D3626D}" type="datetimeFigureOut">
               <a:rPr lang="en-IN" smtClean="0"/>
-              <a:t>23-03-2026</a:t>
+              <a:t>02-04-2026</a:t>
             </a:fld>
             <a:endParaRPr lang="en-IN"/>
           </a:p>
@@ -4781,7 +4783,7 @@
           <a:p>
             <a:fld id="{A544FFC6-13CD-4522-9B98-D20659D3626D}" type="datetimeFigureOut">
               <a:rPr lang="en-IN" smtClean="0"/>
-              <a:t>23-03-2026</a:t>
+              <a:t>02-04-2026</a:t>
             </a:fld>
             <a:endParaRPr lang="en-IN"/>
           </a:p>
@@ -5196,7 +5198,7 @@
           <a:p>
             <a:fld id="{A544FFC6-13CD-4522-9B98-D20659D3626D}" type="datetimeFigureOut">
               <a:rPr lang="en-IN" smtClean="0"/>
-              <a:t>23-03-2026</a:t>
+              <a:t>02-04-2026</a:t>
             </a:fld>
             <a:endParaRPr lang="en-IN"/>
           </a:p>
@@ -5338,7 +5340,7 @@
           <a:p>
             <a:fld id="{A544FFC6-13CD-4522-9B98-D20659D3626D}" type="datetimeFigureOut">
               <a:rPr lang="en-IN" smtClean="0"/>
-              <a:t>23-03-2026</a:t>
+              <a:t>02-04-2026</a:t>
             </a:fld>
             <a:endParaRPr lang="en-IN"/>
           </a:p>
@@ -5451,7 +5453,7 @@
           <a:p>
             <a:fld id="{A544FFC6-13CD-4522-9B98-D20659D3626D}" type="datetimeFigureOut">
               <a:rPr lang="en-IN" smtClean="0"/>
-              <a:t>23-03-2026</a:t>
+              <a:t>02-04-2026</a:t>
             </a:fld>
             <a:endParaRPr lang="en-IN"/>
           </a:p>
@@ -5764,7 +5766,7 @@
           <a:p>
             <a:fld id="{A544FFC6-13CD-4522-9B98-D20659D3626D}" type="datetimeFigureOut">
               <a:rPr lang="en-IN" smtClean="0"/>
-              <a:t>23-03-2026</a:t>
+              <a:t>02-04-2026</a:t>
             </a:fld>
             <a:endParaRPr lang="en-IN"/>
           </a:p>
@@ -6053,7 +6055,7 @@
           <a:p>
             <a:fld id="{A544FFC6-13CD-4522-9B98-D20659D3626D}" type="datetimeFigureOut">
               <a:rPr lang="en-IN" smtClean="0"/>
-              <a:t>23-03-2026</a:t>
+              <a:t>02-04-2026</a:t>
             </a:fld>
             <a:endParaRPr lang="en-IN"/>
           </a:p>
@@ -6296,7 +6298,7 @@
           <a:p>
             <a:fld id="{A544FFC6-13CD-4522-9B98-D20659D3626D}" type="datetimeFigureOut">
               <a:rPr lang="en-IN" smtClean="0"/>
-              <a:t>23-03-2026</a:t>
+              <a:t>02-04-2026</a:t>
             </a:fld>
             <a:endParaRPr lang="en-IN"/>
           </a:p>
@@ -6845,6 +6847,318 @@
 </p:sld>
 </file>
 
+<file path=ppt/slides/slide10.xml><?xml version="1.0" encoding="utf-8"?>
+<p:sld xmlns:a="http://schemas.openxmlformats.org/drawingml/2006/main" xmlns:r="http://schemas.openxmlformats.org/officeDocument/2006/relationships" xmlns:p="http://schemas.openxmlformats.org/presentationml/2006/main">
+  <p:cSld>
+    <p:spTree>
+      <p:nvGrpSpPr>
+        <p:cNvPr id="1" name=""/>
+        <p:cNvGrpSpPr/>
+        <p:nvPr/>
+      </p:nvGrpSpPr>
+      <p:grpSpPr>
+        <a:xfrm>
+          <a:off x="0" y="0"/>
+          <a:ext cx="0" cy="0"/>
+          <a:chOff x="0" y="0"/>
+          <a:chExt cx="0" cy="0"/>
+        </a:xfrm>
+      </p:grpSpPr>
+      <p:sp>
+        <p:nvSpPr>
+          <p:cNvPr id="2" name="TextBox 1">
+            <a:extLst>
+              <a:ext uri="{FF2B5EF4-FFF2-40B4-BE49-F238E27FC236}">
+                <a16:creationId xmlns:a16="http://schemas.microsoft.com/office/drawing/2014/main" id="{42C732C2-91D3-AA31-1E74-5A70C1340EB5}"/>
+              </a:ext>
+            </a:extLst>
+          </p:cNvPr>
+          <p:cNvSpPr txBox="1"/>
+          <p:nvPr/>
+        </p:nvSpPr>
+        <p:spPr>
+          <a:xfrm>
+            <a:off x="215757" y="143840"/>
+            <a:ext cx="11784458" cy="6524863"/>
+          </a:xfrm>
+          <a:prstGeom prst="rect">
+            <a:avLst/>
+          </a:prstGeom>
+          <a:noFill/>
+        </p:spPr>
+        <p:txBody>
+          <a:bodyPr wrap="square" rtlCol="0">
+            <a:spAutoFit/>
+          </a:bodyPr>
+          <a:lstStyle/>
+          <a:p>
+            <a:pPr algn="just"/>
+            <a:r>
+              <a:rPr lang="en-US" sz="2200" dirty="0">
+                <a:latin typeface="Times New Roman" panose="02020603050405020304" pitchFamily="18" charset="0"/>
+                <a:cs typeface="Times New Roman" panose="02020603050405020304" pitchFamily="18" charset="0"/>
+              </a:rPr>
+              <a:t>You can reach out to me for any guidance, suggestions, or help regarding this system:</a:t>
+            </a:r>
+          </a:p>
+          <a:p>
+            <a:pPr algn="just"/>
+            <a:r>
+              <a:rPr lang="en-US" sz="2200" dirty="0">
+                <a:latin typeface="Times New Roman" panose="02020603050405020304" pitchFamily="18" charset="0"/>
+                <a:cs typeface="Times New Roman" panose="02020603050405020304" pitchFamily="18" charset="0"/>
+              </a:rPr>
+              <a:t>📧 </a:t>
+            </a:r>
+            <a:r>
+              <a:rPr lang="en-US" sz="2200" dirty="0">
+                <a:latin typeface="Times New Roman" panose="02020603050405020304" pitchFamily="18" charset="0"/>
+                <a:cs typeface="Times New Roman" panose="02020603050405020304" pitchFamily="18" charset="0"/>
+                <a:hlinkClick r:id="rId2"/>
+              </a:rPr>
+              <a:t>mailto:rawatmadhurima4@gmail.com</a:t>
+            </a:r>
+            <a:r>
+              <a:rPr lang="en-US" sz="2200" dirty="0">
+                <a:latin typeface="Times New Roman" panose="02020603050405020304" pitchFamily="18" charset="0"/>
+                <a:cs typeface="Times New Roman" panose="02020603050405020304" pitchFamily="18" charset="0"/>
+              </a:rPr>
+              <a:t>	🔗 </a:t>
+            </a:r>
+            <a:r>
+              <a:rPr lang="en-US" sz="2200" dirty="0">
+                <a:latin typeface="Times New Roman" panose="02020603050405020304" pitchFamily="18" charset="0"/>
+                <a:cs typeface="Times New Roman" panose="02020603050405020304" pitchFamily="18" charset="0"/>
+                <a:hlinkClick r:id="rId3"/>
+              </a:rPr>
+              <a:t>LinkedIn: Madhurima Rawat</a:t>
+            </a:r>
+            <a:endParaRPr lang="en-US" sz="2200" dirty="0">
+              <a:latin typeface="Times New Roman" panose="02020603050405020304" pitchFamily="18" charset="0"/>
+              <a:cs typeface="Times New Roman" panose="02020603050405020304" pitchFamily="18" charset="0"/>
+            </a:endParaRPr>
+          </a:p>
+          <a:p>
+            <a:pPr algn="just"/>
+            <a:endParaRPr lang="en-US" sz="2200" dirty="0">
+              <a:latin typeface="Times New Roman" panose="02020603050405020304" pitchFamily="18" charset="0"/>
+              <a:cs typeface="Times New Roman" panose="02020603050405020304" pitchFamily="18" charset="0"/>
+            </a:endParaRPr>
+          </a:p>
+          <a:p>
+            <a:pPr algn="just"/>
+            <a:r>
+              <a:rPr lang="en-US" sz="2200" dirty="0">
+                <a:latin typeface="Times New Roman" panose="02020603050405020304" pitchFamily="18" charset="0"/>
+                <a:cs typeface="Times New Roman" panose="02020603050405020304" pitchFamily="18" charset="0"/>
+              </a:rPr>
+              <a:t>If you’re looking for useful products, here are some recommendations:</a:t>
+            </a:r>
+          </a:p>
+          <a:p>
+            <a:pPr algn="just"/>
+            <a:endParaRPr lang="en-US" sz="2200" dirty="0">
+              <a:latin typeface="Times New Roman" panose="02020603050405020304" pitchFamily="18" charset="0"/>
+              <a:cs typeface="Times New Roman" panose="02020603050405020304" pitchFamily="18" charset="0"/>
+            </a:endParaRPr>
+          </a:p>
+          <a:p>
+            <a:pPr marL="342900" indent="-342900" algn="just">
+              <a:buFont typeface="+mj-lt"/>
+              <a:buAutoNum type="arabicPeriod"/>
+            </a:pPr>
+            <a:r>
+              <a:rPr lang="en-US" sz="2200" dirty="0">
+                <a:latin typeface="Times New Roman" panose="02020603050405020304" pitchFamily="18" charset="0"/>
+                <a:cs typeface="Times New Roman" panose="02020603050405020304" pitchFamily="18" charset="0"/>
+                <a:hlinkClick r:id="rId4"/>
+              </a:rPr>
+              <a:t>File with plastic sleeves </a:t>
+            </a:r>
+            <a:r>
+              <a:rPr lang="en-US" sz="2200" dirty="0">
+                <a:latin typeface="Times New Roman" panose="02020603050405020304" pitchFamily="18" charset="0"/>
+                <a:cs typeface="Times New Roman" panose="02020603050405020304" pitchFamily="18" charset="0"/>
+              </a:rPr>
+              <a:t>- best for storing original documents</a:t>
+            </a:r>
+          </a:p>
+          <a:p>
+            <a:pPr marL="342900" indent="-342900" algn="just">
+              <a:buFont typeface="+mj-lt"/>
+              <a:buAutoNum type="arabicPeriod"/>
+            </a:pPr>
+            <a:r>
+              <a:rPr lang="en-US" sz="2200" dirty="0">
+                <a:latin typeface="Times New Roman" panose="02020603050405020304" pitchFamily="18" charset="0"/>
+                <a:cs typeface="Times New Roman" panose="02020603050405020304" pitchFamily="18" charset="0"/>
+                <a:hlinkClick r:id="rId5"/>
+              </a:rPr>
+              <a:t>Card holder </a:t>
+            </a:r>
+            <a:r>
+              <a:rPr lang="en-US" sz="2200" dirty="0">
+                <a:latin typeface="Times New Roman" panose="02020603050405020304" pitchFamily="18" charset="0"/>
+                <a:cs typeface="Times New Roman" panose="02020603050405020304" pitchFamily="18" charset="0"/>
+              </a:rPr>
+              <a:t>-  very useful and handy for ID cards</a:t>
+            </a:r>
+          </a:p>
+          <a:p>
+            <a:pPr marL="342900" indent="-342900" algn="just">
+              <a:buFont typeface="+mj-lt"/>
+              <a:buAutoNum type="arabicPeriod"/>
+            </a:pPr>
+            <a:r>
+              <a:rPr lang="en-US" sz="2200" dirty="0">
+                <a:latin typeface="Times New Roman" panose="02020603050405020304" pitchFamily="18" charset="0"/>
+                <a:cs typeface="Times New Roman" panose="02020603050405020304" pitchFamily="18" charset="0"/>
+                <a:hlinkClick r:id="rId6"/>
+              </a:rPr>
+              <a:t>Clear bag / chic button folder </a:t>
+            </a:r>
+            <a:r>
+              <a:rPr lang="en-US" sz="2200" dirty="0">
+                <a:latin typeface="Times New Roman" panose="02020603050405020304" pitchFamily="18" charset="0"/>
+                <a:cs typeface="Times New Roman" panose="02020603050405020304" pitchFamily="18" charset="0"/>
+              </a:rPr>
+              <a:t>- for general document storage</a:t>
+            </a:r>
+          </a:p>
+          <a:p>
+            <a:pPr marL="342900" indent="-342900" algn="just">
+              <a:buFont typeface="+mj-lt"/>
+              <a:buAutoNum type="arabicPeriod"/>
+            </a:pPr>
+            <a:r>
+              <a:rPr lang="en-US" sz="2200" dirty="0">
+                <a:latin typeface="Times New Roman" panose="02020603050405020304" pitchFamily="18" charset="0"/>
+                <a:cs typeface="Times New Roman" panose="02020603050405020304" pitchFamily="18" charset="0"/>
+                <a:hlinkClick r:id="rId7"/>
+              </a:rPr>
+              <a:t>Clear zip folder</a:t>
+            </a:r>
+            <a:r>
+              <a:rPr lang="en-US" sz="2200" dirty="0">
+                <a:latin typeface="Times New Roman" panose="02020603050405020304" pitchFamily="18" charset="0"/>
+                <a:cs typeface="Times New Roman" panose="02020603050405020304" pitchFamily="18" charset="0"/>
+              </a:rPr>
+              <a:t> - secure and easy to carry</a:t>
+            </a:r>
+          </a:p>
+          <a:p>
+            <a:pPr marL="342900" indent="-342900" algn="just">
+              <a:buFont typeface="+mj-lt"/>
+              <a:buAutoNum type="arabicPeriod"/>
+            </a:pPr>
+            <a:r>
+              <a:rPr lang="en-US" sz="2200" dirty="0">
+                <a:latin typeface="Times New Roman" panose="02020603050405020304" pitchFamily="18" charset="0"/>
+                <a:cs typeface="Times New Roman" panose="02020603050405020304" pitchFamily="18" charset="0"/>
+                <a:hlinkClick r:id="rId8"/>
+              </a:rPr>
+              <a:t>Plastic expandable folder </a:t>
+            </a:r>
+            <a:r>
+              <a:rPr lang="en-US" sz="2200" dirty="0">
+                <a:latin typeface="Times New Roman" panose="02020603050405020304" pitchFamily="18" charset="0"/>
+                <a:cs typeface="Times New Roman" panose="02020603050405020304" pitchFamily="18" charset="0"/>
+              </a:rPr>
+              <a:t>- ideal for organizing multiple documents</a:t>
+            </a:r>
+          </a:p>
+          <a:p>
+            <a:pPr marL="342900" indent="-342900" algn="just">
+              <a:buFont typeface="+mj-lt"/>
+              <a:buAutoNum type="arabicPeriod"/>
+            </a:pPr>
+            <a:r>
+              <a:rPr lang="en-US" sz="2200" dirty="0">
+                <a:latin typeface="Times New Roman" panose="02020603050405020304" pitchFamily="18" charset="0"/>
+                <a:cs typeface="Times New Roman" panose="02020603050405020304" pitchFamily="18" charset="0"/>
+                <a:hlinkClick r:id="rId9"/>
+              </a:rPr>
+              <a:t>Plastic expandable professional folder </a:t>
+            </a:r>
+            <a:r>
+              <a:rPr lang="en-US" sz="2200" dirty="0">
+                <a:latin typeface="Times New Roman" panose="02020603050405020304" pitchFamily="18" charset="0"/>
+                <a:cs typeface="Times New Roman" panose="02020603050405020304" pitchFamily="18" charset="0"/>
+              </a:rPr>
+              <a:t>- suitable for office use</a:t>
+            </a:r>
+          </a:p>
+          <a:p>
+            <a:pPr algn="just"/>
+            <a:endParaRPr lang="en-US" sz="2200" dirty="0">
+              <a:latin typeface="Times New Roman" panose="02020603050405020304" pitchFamily="18" charset="0"/>
+              <a:cs typeface="Times New Roman" panose="02020603050405020304" pitchFamily="18" charset="0"/>
+            </a:endParaRPr>
+          </a:p>
+          <a:p>
+            <a:pPr algn="just"/>
+            <a:r>
+              <a:rPr lang="en-US" sz="2200" dirty="0">
+                <a:latin typeface="Times New Roman" panose="02020603050405020304" pitchFamily="18" charset="0"/>
+                <a:cs typeface="Times New Roman" panose="02020603050405020304" pitchFamily="18" charset="0"/>
+              </a:rPr>
+              <a:t>These product links are shared for general reference. You can check reviews before purchasing, or simply find similar options at your nearest stationery shop.</a:t>
+            </a:r>
+          </a:p>
+          <a:p>
+            <a:pPr algn="just"/>
+            <a:r>
+              <a:rPr lang="en-US" sz="2200" dirty="0">
+                <a:latin typeface="Times New Roman" panose="02020603050405020304" pitchFamily="18" charset="0"/>
+                <a:cs typeface="Times New Roman" panose="02020603050405020304" pitchFamily="18" charset="0"/>
+              </a:rPr>
+              <a:t>I have also included a slide containing the icons and labels as a separate PDF file, so it can be printed in high quality. I usually get all documents printed in PDF format, as it provides better clarity than image files. You can also convert it to any format of your choice directly from this PPT if needed.</a:t>
+            </a:r>
+          </a:p>
+          <a:p>
+            <a:pPr algn="just"/>
+            <a:r>
+              <a:rPr lang="en-US" sz="2200" b="1" dirty="0">
+                <a:latin typeface="Times New Roman" panose="02020603050405020304" pitchFamily="18" charset="0"/>
+                <a:cs typeface="Times New Roman" panose="02020603050405020304" pitchFamily="18" charset="0"/>
+              </a:rPr>
+              <a:t>If this helped you, do drop a ⭐ on my repository </a:t>
+            </a:r>
+            <a:r>
+              <a:rPr lang="en-IN" sz="2200" dirty="0">
+                <a:latin typeface="Times New Roman" panose="02020603050405020304" pitchFamily="18" charset="0"/>
+                <a:cs typeface="Times New Roman" panose="02020603050405020304" pitchFamily="18" charset="0"/>
+                <a:hlinkClick r:id="rId10"/>
+              </a:rPr>
+              <a:t>https://github.com/madhurimarawat/Essential-Templates-Kit</a:t>
+            </a:r>
+            <a:r>
+              <a:rPr lang="en-US" sz="2200" b="1" dirty="0">
+                <a:latin typeface="Times New Roman" panose="02020603050405020304" pitchFamily="18" charset="0"/>
+                <a:cs typeface="Times New Roman" panose="02020603050405020304" pitchFamily="18" charset="0"/>
+              </a:rPr>
+              <a:t>, it would mean a lot! </a:t>
+            </a:r>
+            <a:endParaRPr lang="en-US" sz="2200" dirty="0">
+              <a:latin typeface="Times New Roman" panose="02020603050405020304" pitchFamily="18" charset="0"/>
+              <a:cs typeface="Times New Roman" panose="02020603050405020304" pitchFamily="18" charset="0"/>
+            </a:endParaRPr>
+          </a:p>
+        </p:txBody>
+      </p:sp>
+    </p:spTree>
+    <p:extLst>
+      <p:ext uri="{BB962C8B-B14F-4D97-AF65-F5344CB8AC3E}">
+        <p14:creationId xmlns:p14="http://schemas.microsoft.com/office/powerpoint/2010/main" val="3054229722"/>
+      </p:ext>
+    </p:extLst>
+  </p:cSld>
+  <p:clrMapOvr>
+    <a:masterClrMapping/>
+  </p:clrMapOvr>
+</p:sld>
+</file>
+
 <file path=ppt/slides/slide2.xml><?xml version="1.0" encoding="utf-8"?>
 <p:sld xmlns:a="http://schemas.openxmlformats.org/drawingml/2006/main" xmlns:r="http://schemas.openxmlformats.org/officeDocument/2006/relationships" xmlns:p="http://schemas.openxmlformats.org/presentationml/2006/main">
   <p:cSld>
@@ -9078,12 +9392,12 @@
         <p:spPr>
           <a:xfrm>
             <a:off x="205483" y="986319"/>
-            <a:ext cx="11712539" cy="5722706"/>
+            <a:ext cx="11986517" cy="5722706"/>
           </a:xfrm>
         </p:spPr>
         <p:txBody>
           <a:bodyPr>
-            <a:normAutofit lnSpcReduction="10000"/>
+            <a:noAutofit/>
           </a:bodyPr>
           <a:lstStyle/>
           <a:p>
@@ -9091,7 +9405,7 @@
               <a:buNone/>
             </a:pPr>
             <a:r>
-              <a:rPr lang="en-US" dirty="0">
+              <a:rPr lang="en-US" sz="2700" dirty="0">
                 <a:latin typeface="Times New Roman" panose="02020603050405020304" pitchFamily="18" charset="0"/>
                 <a:cs typeface="Times New Roman" panose="02020603050405020304" pitchFamily="18" charset="0"/>
               </a:rPr>
@@ -9100,62 +9414,62 @@
           </a:p>
           <a:p>
             <a:r>
-              <a:rPr lang="en-US" dirty="0">
+              <a:rPr lang="en-US" sz="2700" dirty="0">
                 <a:latin typeface="Times New Roman" panose="02020603050405020304" pitchFamily="18" charset="0"/>
                 <a:cs typeface="Times New Roman" panose="02020603050405020304" pitchFamily="18" charset="0"/>
               </a:rPr>
               <a:t>So do this: make index for separate folders as the previous slide says, then do this,</a:t>
             </a:r>
             <a:br>
-              <a:rPr lang="en-US" dirty="0">
+              <a:rPr lang="en-US" sz="2700" dirty="0">
                 <a:latin typeface="Times New Roman" panose="02020603050405020304" pitchFamily="18" charset="0"/>
                 <a:cs typeface="Times New Roman" panose="02020603050405020304" pitchFamily="18" charset="0"/>
               </a:rPr>
             </a:br>
             <a:r>
-              <a:rPr lang="en-US" dirty="0">
+              <a:rPr lang="en-US" sz="2700" dirty="0">
                 <a:latin typeface="Times New Roman" panose="02020603050405020304" pitchFamily="18" charset="0"/>
                 <a:cs typeface="Times New Roman" panose="02020603050405020304" pitchFamily="18" charset="0"/>
               </a:rPr>
               <a:t>Buy </a:t>
             </a:r>
             <a:r>
-              <a:rPr lang="en-US" b="1" dirty="0">
+              <a:rPr lang="en-US" sz="2700" b="1" dirty="0">
                 <a:latin typeface="Times New Roman" panose="02020603050405020304" pitchFamily="18" charset="0"/>
                 <a:cs typeface="Times New Roman" panose="02020603050405020304" pitchFamily="18" charset="0"/>
               </a:rPr>
               <a:t>sticky notes</a:t>
             </a:r>
             <a:r>
-              <a:rPr lang="en-US" dirty="0">
+              <a:rPr lang="en-US" sz="2700" dirty="0">
                 <a:latin typeface="Times New Roman" panose="02020603050405020304" pitchFamily="18" charset="0"/>
                 <a:cs typeface="Times New Roman" panose="02020603050405020304" pitchFamily="18" charset="0"/>
               </a:rPr>
               <a:t>, fold them from the center and paste them on the index page </a:t>
             </a:r>
             <a:r>
-              <a:rPr lang="en-US" b="1" dirty="0">
+              <a:rPr lang="en-US" sz="2700" b="1" dirty="0">
                 <a:latin typeface="Times New Roman" panose="02020603050405020304" pitchFamily="18" charset="0"/>
                 <a:cs typeface="Times New Roman" panose="02020603050405020304" pitchFamily="18" charset="0"/>
               </a:rPr>
               <a:t>corner or edge </a:t>
             </a:r>
             <a:r>
-              <a:rPr lang="en-US" dirty="0">
+              <a:rPr lang="en-US" sz="2700" dirty="0">
                 <a:latin typeface="Times New Roman" panose="02020603050405020304" pitchFamily="18" charset="0"/>
                 <a:cs typeface="Times New Roman" panose="02020603050405020304" pitchFamily="18" charset="0"/>
               </a:rPr>
               <a:t>where they are </a:t>
             </a:r>
             <a:r>
-              <a:rPr lang="en-US" b="1" dirty="0">
+              <a:rPr lang="en-US" sz="2700" b="1" dirty="0">
                 <a:latin typeface="Times New Roman" panose="02020603050405020304" pitchFamily="18" charset="0"/>
                 <a:cs typeface="Times New Roman" panose="02020603050405020304" pitchFamily="18" charset="0"/>
               </a:rPr>
               <a:t>visible</a:t>
             </a:r>
             <a:r>
-              <a:rPr lang="en-US" dirty="0">
+              <a:rPr lang="en-US" sz="2700" dirty="0">
                 <a:latin typeface="Times New Roman" panose="02020603050405020304" pitchFamily="18" charset="0"/>
                 <a:cs typeface="Times New Roman" panose="02020603050405020304" pitchFamily="18" charset="0"/>
               </a:rPr>
@@ -9164,29 +9478,41 @@
           </a:p>
           <a:p>
             <a:r>
-              <a:rPr lang="en-US" dirty="0">
+              <a:rPr lang="en-IN" sz="2700" b="1" dirty="0">
+                <a:latin typeface="Constantia" panose="02030602050306030303" pitchFamily="18" charset="0"/>
+              </a:rPr>
+              <a:t>Index Page → Documents → Next Index Page → Documents → ...</a:t>
+            </a:r>
+            <a:endParaRPr lang="en-US" sz="2700" dirty="0">
+              <a:latin typeface="Times New Roman" panose="02020603050405020304" pitchFamily="18" charset="0"/>
+              <a:cs typeface="Times New Roman" panose="02020603050405020304" pitchFamily="18" charset="0"/>
+            </a:endParaRPr>
+          </a:p>
+          <a:p>
+            <a:r>
+              <a:rPr lang="en-US" sz="2700" dirty="0">
                 <a:latin typeface="Times New Roman" panose="02020603050405020304" pitchFamily="18" charset="0"/>
                 <a:cs typeface="Times New Roman" panose="02020603050405020304" pitchFamily="18" charset="0"/>
               </a:rPr>
               <a:t>Master index: Write like this -</a:t>
             </a:r>
             <a:br>
-              <a:rPr lang="en-US" dirty="0">
+              <a:rPr lang="en-US" sz="2700" dirty="0">
                 <a:latin typeface="Times New Roman" panose="02020603050405020304" pitchFamily="18" charset="0"/>
                 <a:cs typeface="Times New Roman" panose="02020603050405020304" pitchFamily="18" charset="0"/>
               </a:rPr>
             </a:br>
             <a:r>
-              <a:rPr lang="en-US" b="1" dirty="0">
+              <a:rPr lang="en-US" sz="2700" b="1" dirty="0">
                 <a:latin typeface="Times New Roman" panose="02020603050405020304" pitchFamily="18" charset="0"/>
                 <a:cs typeface="Times New Roman" panose="02020603050405020304" pitchFamily="18" charset="0"/>
               </a:rPr>
-              <a:t>Folder name: subcategory → then document names → then same process</a:t>
-            </a:r>
-          </a:p>
-          <a:p>
-            <a:r>
-              <a:rPr lang="en-US" dirty="0">
+              <a:t>Folder name: category → then document names → then same process</a:t>
+            </a:r>
+          </a:p>
+          <a:p>
+            <a:r>
+              <a:rPr lang="en-US" sz="2700" dirty="0">
                 <a:latin typeface="Times New Roman" panose="02020603050405020304" pitchFamily="18" charset="0"/>
                 <a:cs typeface="Times New Roman" panose="02020603050405020304" pitchFamily="18" charset="0"/>
               </a:rPr>
@@ -9209,6 +9535,609 @@
 </file>
 
 <file path=ppt/slides/slide7.xml><?xml version="1.0" encoding="utf-8"?>
+<p:sld xmlns:a="http://schemas.openxmlformats.org/drawingml/2006/main" xmlns:r="http://schemas.openxmlformats.org/officeDocument/2006/relationships" xmlns:p="http://schemas.openxmlformats.org/presentationml/2006/main">
+  <p:cSld>
+    <p:spTree>
+      <p:nvGrpSpPr>
+        <p:cNvPr id="1" name="">
+          <a:extLst>
+            <a:ext uri="{FF2B5EF4-FFF2-40B4-BE49-F238E27FC236}">
+              <a16:creationId xmlns:a16="http://schemas.microsoft.com/office/drawing/2014/main" id="{AD1125E7-FFA0-E7BA-1A40-1DE4B5B93B33}"/>
+            </a:ext>
+          </a:extLst>
+        </p:cNvPr>
+        <p:cNvGrpSpPr/>
+        <p:nvPr/>
+      </p:nvGrpSpPr>
+      <p:grpSpPr>
+        <a:xfrm>
+          <a:off x="0" y="0"/>
+          <a:ext cx="0" cy="0"/>
+          <a:chOff x="0" y="0"/>
+          <a:chExt cx="0" cy="0"/>
+        </a:xfrm>
+      </p:grpSpPr>
+      <p:sp>
+        <p:nvSpPr>
+          <p:cNvPr id="2" name="Title 1">
+            <a:extLst>
+              <a:ext uri="{FF2B5EF4-FFF2-40B4-BE49-F238E27FC236}">
+                <a16:creationId xmlns:a16="http://schemas.microsoft.com/office/drawing/2014/main" id="{0A39D470-5066-2709-8B4B-F24D75AC9B1B}"/>
+              </a:ext>
+            </a:extLst>
+          </p:cNvPr>
+          <p:cNvSpPr>
+            <a:spLocks noGrp="1"/>
+          </p:cNvSpPr>
+          <p:nvPr>
+            <p:ph type="title"/>
+          </p:nvPr>
+        </p:nvSpPr>
+        <p:spPr>
+          <a:xfrm>
+            <a:off x="848475" y="-148583"/>
+            <a:ext cx="10515600" cy="1325563"/>
+          </a:xfrm>
+        </p:spPr>
+        <p:txBody>
+          <a:bodyPr/>
+          <a:lstStyle/>
+          <a:p>
+            <a:pPr algn="ctr"/>
+            <a:r>
+              <a:rPr lang="en-IN" b="1" dirty="0"/>
+              <a:t>Most Usage of a Single Folder</a:t>
+            </a:r>
+          </a:p>
+        </p:txBody>
+      </p:sp>
+      <p:sp>
+        <p:nvSpPr>
+          <p:cNvPr id="5" name="Rectangle 2">
+            <a:extLst>
+              <a:ext uri="{FF2B5EF4-FFF2-40B4-BE49-F238E27FC236}">
+                <a16:creationId xmlns:a16="http://schemas.microsoft.com/office/drawing/2014/main" id="{DAE0A053-0FB9-9CC2-1424-090062FB2636}"/>
+              </a:ext>
+            </a:extLst>
+          </p:cNvPr>
+          <p:cNvSpPr>
+            <a:spLocks noGrp="1" noChangeArrowheads="1"/>
+          </p:cNvSpPr>
+          <p:nvPr>
+            <p:ph idx="1"/>
+          </p:nvPr>
+        </p:nvSpPr>
+        <p:spPr bwMode="auto">
+          <a:xfrm>
+            <a:off x="205483" y="825731"/>
+            <a:ext cx="11835829" cy="5863144"/>
+          </a:xfrm>
+          <a:prstGeom prst="rect">
+            <a:avLst/>
+          </a:prstGeom>
+          <a:noFill/>
+          <a:ln>
+            <a:noFill/>
+          </a:ln>
+          <a:effectLst/>
+          <a:extLst>
+            <a:ext uri="{909E8E84-426E-40DD-AFC4-6F175D3DCCD1}">
+              <a14:hiddenFill xmlns:a14="http://schemas.microsoft.com/office/drawing/2010/main">
+                <a:solidFill>
+                  <a:schemeClr val="accent1"/>
+                </a:solidFill>
+              </a14:hiddenFill>
+            </a:ext>
+            <a:ext uri="{91240B29-F687-4F45-9708-019B960494DF}">
+              <a14:hiddenLine xmlns:a14="http://schemas.microsoft.com/office/drawing/2010/main" w="9525">
+                <a:solidFill>
+                  <a:schemeClr val="tx1"/>
+                </a:solidFill>
+                <a:miter lim="800000"/>
+                <a:headEnd/>
+                <a:tailEnd/>
+              </a14:hiddenLine>
+            </a:ext>
+            <a:ext uri="{AF507438-7753-43E0-B8FC-AC1667EBCBE1}">
+              <a14:hiddenEffects xmlns:a14="http://schemas.microsoft.com/office/drawing/2010/main">
+                <a:effectLst>
+                  <a:outerShdw dist="35921" dir="2700000" algn="ctr" rotWithShape="0">
+                    <a:schemeClr val="bg2"/>
+                  </a:outerShdw>
+                </a:effectLst>
+              </a14:hiddenEffects>
+            </a:ext>
+          </a:extLst>
+        </p:spPr>
+        <p:txBody>
+          <a:bodyPr vert="horz" wrap="square" lIns="91440" tIns="45720" rIns="91440" bIns="45720" numCol="1" anchor="ctr" anchorCtr="0" compatLnSpc="1">
+            <a:prstTxWarp prst="textNoShape">
+              <a:avLst/>
+            </a:prstTxWarp>
+            <a:spAutoFit/>
+          </a:bodyPr>
+          <a:lstStyle/>
+          <a:p>
+            <a:pPr marL="0" marR="0" lvl="0" indent="0" algn="just" defTabSz="914400" rtl="0" eaLnBrk="0" fontAlgn="base" latinLnBrk="0" hangingPunct="0">
+              <a:lnSpc>
+                <a:spcPct val="100000"/>
+              </a:lnSpc>
+              <a:spcBef>
+                <a:spcPct val="0"/>
+              </a:spcBef>
+              <a:spcAft>
+                <a:spcPct val="0"/>
+              </a:spcAft>
+              <a:buClrTx/>
+              <a:buSzTx/>
+              <a:buFontTx/>
+              <a:buNone/>
+              <a:tabLst/>
+            </a:pPr>
+            <a:r>
+              <a:rPr kumimoji="0" lang="en-US" altLang="en-US" sz="2500" b="0" i="0" u="none" strike="noStrike" cap="none" normalizeH="0" baseline="0" dirty="0">
+                <a:ln>
+                  <a:noFill/>
+                </a:ln>
+                <a:solidFill>
+                  <a:schemeClr val="tx1"/>
+                </a:solidFill>
+                <a:effectLst/>
+                <a:latin typeface="Arial" panose="020B0604020202020204" pitchFamily="34" charset="0"/>
+              </a:rPr>
+              <a:t>You can also use colored pages as index dividers within a single folder. For example, start with a red sheet as your first index page. On this page, paste sticky notes horizontally (sideways) along the edge, using the same color for a clean and consistent look. To make them durable, laminate the sticky note area using wide transparent tape.</a:t>
+            </a:r>
+          </a:p>
+          <a:p>
+            <a:pPr marL="457200" indent="-457200" algn="just" eaLnBrk="0" fontAlgn="base" hangingPunct="0">
+              <a:lnSpc>
+                <a:spcPct val="100000"/>
+              </a:lnSpc>
+              <a:spcBef>
+                <a:spcPct val="0"/>
+              </a:spcBef>
+              <a:spcAft>
+                <a:spcPct val="0"/>
+              </a:spcAft>
+              <a:buFont typeface="+mj-lt"/>
+              <a:buAutoNum type="arabicPeriod"/>
+            </a:pPr>
+            <a:r>
+              <a:rPr kumimoji="0" lang="en-US" altLang="en-US" sz="2500" b="0" i="0" u="none" strike="noStrike" cap="none" normalizeH="0" baseline="0" dirty="0">
+                <a:ln>
+                  <a:noFill/>
+                </a:ln>
+                <a:solidFill>
+                  <a:schemeClr val="tx1"/>
+                </a:solidFill>
+                <a:effectLst/>
+                <a:latin typeface="Arial" panose="020B0604020202020204" pitchFamily="34" charset="0"/>
+              </a:rPr>
+              <a:t>Repeat this process for each section: take a colored page as the index, add sticky notes, secure them with tape, and then label each tab properly. While labeling, write the document name along with the number of photocopies, clearly mentioning how many are colored and how many are black and white. If you are including original documents, make sure to note that as well.</a:t>
+            </a:r>
+          </a:p>
+          <a:p>
+            <a:pPr marL="457200" marR="0" lvl="0" indent="-457200" algn="just" defTabSz="914400" rtl="0" eaLnBrk="0" fontAlgn="base" latinLnBrk="0" hangingPunct="0">
+              <a:lnSpc>
+                <a:spcPct val="100000"/>
+              </a:lnSpc>
+              <a:spcBef>
+                <a:spcPct val="0"/>
+              </a:spcBef>
+              <a:spcAft>
+                <a:spcPct val="0"/>
+              </a:spcAft>
+              <a:buClrTx/>
+              <a:buSzTx/>
+              <a:buFont typeface="+mj-lt"/>
+              <a:buAutoNum type="arabicPeriod"/>
+              <a:tabLst/>
+            </a:pPr>
+            <a:r>
+              <a:rPr kumimoji="0" lang="en-US" altLang="en-US" sz="2500" b="0" i="0" u="none" strike="noStrike" cap="none" normalizeH="0" baseline="0" dirty="0">
+                <a:ln>
+                  <a:noFill/>
+                </a:ln>
+                <a:solidFill>
+                  <a:schemeClr val="tx1"/>
+                </a:solidFill>
+                <a:effectLst/>
+                <a:latin typeface="Arial" panose="020B0604020202020204" pitchFamily="34" charset="0"/>
+              </a:rPr>
+              <a:t>Arrange everything in a sequence like this: first index page followed by its documents, then the second index page followed by its documents, and so on. This structure allows you to manage multiple sections neatly within the same folder without confusion.</a:t>
+            </a:r>
+          </a:p>
+          <a:p>
+            <a:pPr marL="0" lvl="0" indent="0" algn="just" eaLnBrk="0" fontAlgn="base" hangingPunct="0">
+              <a:lnSpc>
+                <a:spcPct val="100000"/>
+              </a:lnSpc>
+              <a:spcBef>
+                <a:spcPct val="0"/>
+              </a:spcBef>
+              <a:spcAft>
+                <a:spcPct val="0"/>
+              </a:spcAft>
+              <a:buNone/>
+            </a:pPr>
+            <a:r>
+              <a:rPr lang="en-IN" sz="2500" b="1" dirty="0">
+                <a:latin typeface="Constantia" panose="02030602050306030303" pitchFamily="18" charset="0"/>
+              </a:rPr>
+              <a:t>	Index Page → Documents → Next Index Page → Documents → ...</a:t>
+            </a:r>
+            <a:endParaRPr kumimoji="0" lang="en-US" altLang="en-US" sz="2500" b="1" i="0" u="none" strike="noStrike" cap="none" normalizeH="0" baseline="0" dirty="0">
+              <a:ln>
+                <a:noFill/>
+              </a:ln>
+              <a:solidFill>
+                <a:schemeClr val="tx1"/>
+              </a:solidFill>
+              <a:effectLst/>
+              <a:latin typeface="Constantia" panose="02030602050306030303" pitchFamily="18" charset="0"/>
+            </a:endParaRPr>
+          </a:p>
+        </p:txBody>
+      </p:sp>
+    </p:spTree>
+    <p:extLst>
+      <p:ext uri="{BB962C8B-B14F-4D97-AF65-F5344CB8AC3E}">
+        <p14:creationId xmlns:p14="http://schemas.microsoft.com/office/powerpoint/2010/main" val="1562855170"/>
+      </p:ext>
+    </p:extLst>
+  </p:cSld>
+  <p:clrMapOvr>
+    <a:masterClrMapping/>
+  </p:clrMapOvr>
+</p:sld>
+</file>
+
+<file path=ppt/slides/slide8.xml><?xml version="1.0" encoding="utf-8"?>
+<p:sld xmlns:a="http://schemas.openxmlformats.org/drawingml/2006/main" xmlns:r="http://schemas.openxmlformats.org/officeDocument/2006/relationships" xmlns:p="http://schemas.openxmlformats.org/presentationml/2006/main">
+  <p:cSld>
+    <p:spTree>
+      <p:nvGrpSpPr>
+        <p:cNvPr id="1" name="">
+          <a:extLst>
+            <a:ext uri="{FF2B5EF4-FFF2-40B4-BE49-F238E27FC236}">
+              <a16:creationId xmlns:a16="http://schemas.microsoft.com/office/drawing/2014/main" id="{D48F8DAF-2169-232F-011A-FE7600E83B5A}"/>
+            </a:ext>
+          </a:extLst>
+        </p:cNvPr>
+        <p:cNvGrpSpPr/>
+        <p:nvPr/>
+      </p:nvGrpSpPr>
+      <p:grpSpPr>
+        <a:xfrm>
+          <a:off x="0" y="0"/>
+          <a:ext cx="0" cy="0"/>
+          <a:chOff x="0" y="0"/>
+          <a:chExt cx="0" cy="0"/>
+        </a:xfrm>
+      </p:grpSpPr>
+      <p:sp>
+        <p:nvSpPr>
+          <p:cNvPr id="2" name="Title 1">
+            <a:extLst>
+              <a:ext uri="{FF2B5EF4-FFF2-40B4-BE49-F238E27FC236}">
+                <a16:creationId xmlns:a16="http://schemas.microsoft.com/office/drawing/2014/main" id="{922E4B55-7ABA-69D4-18F3-995968BE1572}"/>
+              </a:ext>
+            </a:extLst>
+          </p:cNvPr>
+          <p:cNvSpPr>
+            <a:spLocks noGrp="1"/>
+          </p:cNvSpPr>
+          <p:nvPr>
+            <p:ph type="title"/>
+          </p:nvPr>
+        </p:nvSpPr>
+        <p:spPr>
+          <a:xfrm>
+            <a:off x="848475" y="-148583"/>
+            <a:ext cx="10515600" cy="1325563"/>
+          </a:xfrm>
+        </p:spPr>
+        <p:txBody>
+          <a:bodyPr/>
+          <a:lstStyle/>
+          <a:p>
+            <a:pPr algn="ctr"/>
+            <a:r>
+              <a:rPr lang="en-IN" b="1" dirty="0"/>
+              <a:t>Most Usage of a Single Folder</a:t>
+            </a:r>
+          </a:p>
+        </p:txBody>
+      </p:sp>
+      <p:sp>
+        <p:nvSpPr>
+          <p:cNvPr id="4" name="Rectangle 2">
+            <a:extLst>
+              <a:ext uri="{FF2B5EF4-FFF2-40B4-BE49-F238E27FC236}">
+                <a16:creationId xmlns:a16="http://schemas.microsoft.com/office/drawing/2014/main" id="{B1A67FB4-5E98-40E9-2353-B87BB7250643}"/>
+              </a:ext>
+            </a:extLst>
+          </p:cNvPr>
+          <p:cNvSpPr>
+            <a:spLocks noGrp="1" noChangeArrowheads="1"/>
+          </p:cNvSpPr>
+          <p:nvPr>
+            <p:ph idx="1"/>
+          </p:nvPr>
+        </p:nvSpPr>
+        <p:spPr bwMode="auto">
+          <a:xfrm>
+            <a:off x="233916" y="727413"/>
+            <a:ext cx="11797122" cy="6109365"/>
+          </a:xfrm>
+          <a:prstGeom prst="rect">
+            <a:avLst/>
+          </a:prstGeom>
+          <a:noFill/>
+          <a:ln>
+            <a:noFill/>
+          </a:ln>
+          <a:effectLst/>
+          <a:extLst>
+            <a:ext uri="{909E8E84-426E-40DD-AFC4-6F175D3DCCD1}">
+              <a14:hiddenFill xmlns:a14="http://schemas.microsoft.com/office/drawing/2010/main">
+                <a:solidFill>
+                  <a:schemeClr val="accent1"/>
+                </a:solidFill>
+              </a14:hiddenFill>
+            </a:ext>
+            <a:ext uri="{91240B29-F687-4F45-9708-019B960494DF}">
+              <a14:hiddenLine xmlns:a14="http://schemas.microsoft.com/office/drawing/2010/main" w="9525">
+                <a:solidFill>
+                  <a:schemeClr val="tx1"/>
+                </a:solidFill>
+                <a:miter lim="800000"/>
+                <a:headEnd/>
+                <a:tailEnd/>
+              </a14:hiddenLine>
+            </a:ext>
+            <a:ext uri="{AF507438-7753-43E0-B8FC-AC1667EBCBE1}">
+              <a14:hiddenEffects xmlns:a14="http://schemas.microsoft.com/office/drawing/2010/main">
+                <a:effectLst>
+                  <a:outerShdw dist="35921" dir="2700000" algn="ctr" rotWithShape="0">
+                    <a:schemeClr val="bg2"/>
+                  </a:outerShdw>
+                </a:effectLst>
+              </a14:hiddenEffects>
+            </a:ext>
+          </a:extLst>
+        </p:spPr>
+        <p:txBody>
+          <a:bodyPr vert="horz" wrap="square" lIns="91440" tIns="45720" rIns="91440" bIns="45720" numCol="1" anchor="ctr" anchorCtr="0" compatLnSpc="1">
+            <a:prstTxWarp prst="textNoShape">
+              <a:avLst/>
+            </a:prstTxWarp>
+            <a:spAutoFit/>
+          </a:bodyPr>
+          <a:lstStyle/>
+          <a:p>
+            <a:pPr marL="457200" marR="0" lvl="0" indent="-457200" algn="just" defTabSz="914400" rtl="0" eaLnBrk="0" fontAlgn="base" latinLnBrk="0" hangingPunct="0">
+              <a:lnSpc>
+                <a:spcPct val="100000"/>
+              </a:lnSpc>
+              <a:spcBef>
+                <a:spcPct val="0"/>
+              </a:spcBef>
+              <a:spcAft>
+                <a:spcPct val="0"/>
+              </a:spcAft>
+              <a:buClrTx/>
+              <a:buSzTx/>
+              <a:buFont typeface="+mj-lt"/>
+              <a:buAutoNum type="arabicPeriod" startAt="3"/>
+              <a:tabLst/>
+            </a:pPr>
+            <a:r>
+              <a:rPr kumimoji="0" lang="en-US" altLang="en-US" sz="2300" b="0" i="0" u="none" strike="noStrike" cap="none" normalizeH="0" baseline="0" dirty="0">
+                <a:ln>
+                  <a:noFill/>
+                </a:ln>
+                <a:solidFill>
+                  <a:schemeClr val="tx1"/>
+                </a:solidFill>
+                <a:effectLst/>
+                <a:latin typeface="Arial" panose="020B0604020202020204" pitchFamily="34" charset="0"/>
+              </a:rPr>
+              <a:t>I have also included </a:t>
+            </a:r>
+            <a:r>
+              <a:rPr kumimoji="0" lang="en-US" altLang="en-US" sz="2300" b="1" i="0" u="none" strike="noStrike" cap="none" normalizeH="0" baseline="0" dirty="0">
+                <a:ln>
+                  <a:noFill/>
+                </a:ln>
+                <a:solidFill>
+                  <a:schemeClr val="tx1"/>
+                </a:solidFill>
+                <a:effectLst/>
+                <a:latin typeface="Arial" panose="020B0604020202020204" pitchFamily="34" charset="0"/>
+              </a:rPr>
+              <a:t>formats for both the index and the master index </a:t>
+            </a:r>
+            <a:r>
+              <a:rPr kumimoji="0" lang="en-US" altLang="en-US" sz="2300" b="0" i="0" u="none" strike="noStrike" cap="none" normalizeH="0" baseline="0" dirty="0">
+                <a:ln>
+                  <a:noFill/>
+                </a:ln>
+                <a:solidFill>
+                  <a:schemeClr val="tx1"/>
+                </a:solidFill>
+                <a:effectLst/>
+                <a:latin typeface="Arial" panose="020B0604020202020204" pitchFamily="34" charset="0"/>
+              </a:rPr>
+              <a:t>in the directory. You can print these, fill them in, and attach sticky notes on the side corners in a zigzag pattern. This placement makes each section more visible and easier to access.</a:t>
+            </a:r>
+          </a:p>
+          <a:p>
+            <a:pPr marL="457200" marR="0" lvl="0" indent="-457200" algn="just" defTabSz="914400" rtl="0" eaLnBrk="0" fontAlgn="base" latinLnBrk="0" hangingPunct="0">
+              <a:lnSpc>
+                <a:spcPct val="100000"/>
+              </a:lnSpc>
+              <a:spcBef>
+                <a:spcPct val="0"/>
+              </a:spcBef>
+              <a:spcAft>
+                <a:spcPct val="0"/>
+              </a:spcAft>
+              <a:buClrTx/>
+              <a:buSzTx/>
+              <a:buFont typeface="+mj-lt"/>
+              <a:buAutoNum type="arabicPeriod" startAt="3"/>
+              <a:tabLst/>
+            </a:pPr>
+            <a:r>
+              <a:rPr kumimoji="0" lang="en-US" altLang="en-US" sz="2300" b="0" i="0" u="none" strike="noStrike" cap="none" normalizeH="0" baseline="0" dirty="0">
+                <a:ln>
+                  <a:noFill/>
+                </a:ln>
+                <a:solidFill>
+                  <a:schemeClr val="tx1"/>
+                </a:solidFill>
+                <a:effectLst/>
+                <a:latin typeface="Arial" panose="020B0604020202020204" pitchFamily="34" charset="0"/>
+              </a:rPr>
+              <a:t>Additionally, you can assign different colors to personal index pages (like the first or second index) so that they align with your overall color-coding system and make navigation more intuitive.</a:t>
+            </a:r>
+          </a:p>
+          <a:p>
+            <a:pPr marL="457200" marR="0" lvl="0" indent="-457200" algn="just" defTabSz="914400" rtl="0" eaLnBrk="0" fontAlgn="base" latinLnBrk="0" hangingPunct="0">
+              <a:lnSpc>
+                <a:spcPct val="100000"/>
+              </a:lnSpc>
+              <a:spcBef>
+                <a:spcPct val="0"/>
+              </a:spcBef>
+              <a:spcAft>
+                <a:spcPct val="0"/>
+              </a:spcAft>
+              <a:buClrTx/>
+              <a:buSzTx/>
+              <a:buFont typeface="+mj-lt"/>
+              <a:buAutoNum type="arabicPeriod" startAt="3"/>
+              <a:tabLst/>
+            </a:pPr>
+            <a:r>
+              <a:rPr kumimoji="0" lang="en-US" altLang="en-US" sz="2300" b="0" i="0" u="none" strike="noStrike" cap="none" normalizeH="0" baseline="0" dirty="0">
+                <a:ln>
+                  <a:noFill/>
+                </a:ln>
+                <a:solidFill>
+                  <a:schemeClr val="tx1"/>
+                </a:solidFill>
+                <a:effectLst/>
+                <a:latin typeface="Arial" panose="020B0604020202020204" pitchFamily="34" charset="0"/>
+              </a:rPr>
+              <a:t>To keep everything manageable, try to limit each folder to a maximum of </a:t>
+            </a:r>
+            <a:r>
+              <a:rPr kumimoji="0" lang="en-US" altLang="en-US" sz="2300" b="1" i="0" u="none" strike="noStrike" cap="none" normalizeH="0" baseline="0" dirty="0">
+                <a:ln>
+                  <a:noFill/>
+                </a:ln>
+                <a:solidFill>
+                  <a:schemeClr val="tx1"/>
+                </a:solidFill>
+                <a:effectLst/>
+                <a:latin typeface="Arial" panose="020B0604020202020204" pitchFamily="34" charset="0"/>
+              </a:rPr>
+              <a:t>five categories</a:t>
+            </a:r>
+            <a:r>
+              <a:rPr kumimoji="0" lang="en-US" altLang="en-US" sz="2300" b="0" i="0" u="none" strike="noStrike" cap="none" normalizeH="0" baseline="0" dirty="0">
+                <a:ln>
+                  <a:noFill/>
+                </a:ln>
+                <a:solidFill>
+                  <a:schemeClr val="tx1"/>
+                </a:solidFill>
+                <a:effectLst/>
+                <a:latin typeface="Arial" panose="020B0604020202020204" pitchFamily="34" charset="0"/>
+              </a:rPr>
+              <a:t>. This also makes color coding much easier to follow and visually clear.</a:t>
+            </a:r>
+          </a:p>
+          <a:p>
+            <a:pPr marL="457200" marR="0" lvl="0" indent="-457200" algn="just" defTabSz="914400" rtl="0" eaLnBrk="0" fontAlgn="base" latinLnBrk="0" hangingPunct="0">
+              <a:lnSpc>
+                <a:spcPct val="100000"/>
+              </a:lnSpc>
+              <a:spcBef>
+                <a:spcPct val="0"/>
+              </a:spcBef>
+              <a:spcAft>
+                <a:spcPct val="0"/>
+              </a:spcAft>
+              <a:buClrTx/>
+              <a:buSzTx/>
+              <a:buFont typeface="+mj-lt"/>
+              <a:buAutoNum type="arabicPeriod" startAt="3"/>
+              <a:tabLst/>
+            </a:pPr>
+            <a:r>
+              <a:rPr kumimoji="0" lang="en-US" altLang="en-US" sz="2300" b="0" i="0" u="none" strike="noStrike" cap="none" normalizeH="0" baseline="0" dirty="0">
+                <a:ln>
+                  <a:noFill/>
+                </a:ln>
+                <a:solidFill>
+                  <a:schemeClr val="tx1"/>
+                </a:solidFill>
+                <a:effectLst/>
+                <a:latin typeface="Arial" panose="020B0604020202020204" pitchFamily="34" charset="0"/>
+              </a:rPr>
+              <a:t>If you have more documents, you can maintain a separate master index for each folder. For example, you can list categories like “Vehicles” and assign it a color such as red, then “Degree” as blue, and continue similarly. This helps you track both the sequence and the color mapping at a glance.</a:t>
+            </a:r>
+          </a:p>
+          <a:p>
+            <a:pPr marL="457200" marR="0" lvl="0" indent="-457200" algn="just" defTabSz="914400" rtl="0" eaLnBrk="0" fontAlgn="base" latinLnBrk="0" hangingPunct="0">
+              <a:lnSpc>
+                <a:spcPct val="100000"/>
+              </a:lnSpc>
+              <a:spcBef>
+                <a:spcPct val="0"/>
+              </a:spcBef>
+              <a:spcAft>
+                <a:spcPct val="0"/>
+              </a:spcAft>
+              <a:buClrTx/>
+              <a:buSzTx/>
+              <a:buFont typeface="+mj-lt"/>
+              <a:buAutoNum type="arabicPeriod" startAt="3"/>
+              <a:tabLst/>
+            </a:pPr>
+            <a:r>
+              <a:rPr kumimoji="0" lang="en-US" altLang="en-US" sz="2300" b="0" i="0" u="none" strike="noStrike" cap="none" normalizeH="0" baseline="0" dirty="0">
+                <a:ln>
+                  <a:noFill/>
+                </a:ln>
+                <a:solidFill>
+                  <a:schemeClr val="tx1"/>
+                </a:solidFill>
+                <a:effectLst/>
+                <a:latin typeface="Arial" panose="020B0604020202020204" pitchFamily="34" charset="0"/>
+              </a:rPr>
+              <a:t>You can also include this information in a main master index by listing folder categories sequentially. Alternatively, since the sticky notes are wide and laminated, you can quickly identify sections directly from the folder itself without always referring back to the index.</a:t>
+            </a:r>
+          </a:p>
+        </p:txBody>
+      </p:sp>
+    </p:spTree>
+    <p:extLst>
+      <p:ext uri="{BB962C8B-B14F-4D97-AF65-F5344CB8AC3E}">
+        <p14:creationId xmlns:p14="http://schemas.microsoft.com/office/powerpoint/2010/main" val="1666783981"/>
+      </p:ext>
+    </p:extLst>
+  </p:cSld>
+  <p:clrMapOvr>
+    <a:masterClrMapping/>
+  </p:clrMapOvr>
+</p:sld>
+</file>
+
+<file path=ppt/slides/slide9.xml><?xml version="1.0" encoding="utf-8"?>
 <p:sld xmlns:a="http://schemas.openxmlformats.org/drawingml/2006/main" xmlns:r="http://schemas.openxmlformats.org/officeDocument/2006/relationships" xmlns:p="http://schemas.openxmlformats.org/presentationml/2006/main">
   <p:cSld>
     <p:spTree>
@@ -9281,7 +10210,7 @@
             <p:ph idx="1"/>
             <p:extLst>
               <p:ext uri="{D42A27DB-BD31-4B8C-83A1-F6EECF244321}">
-                <p14:modId xmlns:p14="http://schemas.microsoft.com/office/powerpoint/2010/main" val="331375346"/>
+                <p14:modId xmlns:p14="http://schemas.microsoft.com/office/powerpoint/2010/main" val="600299107"/>
               </p:ext>
             </p:extLst>
           </p:nvPr>
@@ -9300,318 +10229,6 @@
     <p:extLst>
       <p:ext uri="{BB962C8B-B14F-4D97-AF65-F5344CB8AC3E}">
         <p14:creationId xmlns:p14="http://schemas.microsoft.com/office/powerpoint/2010/main" val="4260442206"/>
-      </p:ext>
-    </p:extLst>
-  </p:cSld>
-  <p:clrMapOvr>
-    <a:masterClrMapping/>
-  </p:clrMapOvr>
-</p:sld>
-</file>
-
-<file path=ppt/slides/slide8.xml><?xml version="1.0" encoding="utf-8"?>
-<p:sld xmlns:a="http://schemas.openxmlformats.org/drawingml/2006/main" xmlns:r="http://schemas.openxmlformats.org/officeDocument/2006/relationships" xmlns:p="http://schemas.openxmlformats.org/presentationml/2006/main">
-  <p:cSld>
-    <p:spTree>
-      <p:nvGrpSpPr>
-        <p:cNvPr id="1" name=""/>
-        <p:cNvGrpSpPr/>
-        <p:nvPr/>
-      </p:nvGrpSpPr>
-      <p:grpSpPr>
-        <a:xfrm>
-          <a:off x="0" y="0"/>
-          <a:ext cx="0" cy="0"/>
-          <a:chOff x="0" y="0"/>
-          <a:chExt cx="0" cy="0"/>
-        </a:xfrm>
-      </p:grpSpPr>
-      <p:sp>
-        <p:nvSpPr>
-          <p:cNvPr id="2" name="TextBox 1">
-            <a:extLst>
-              <a:ext uri="{FF2B5EF4-FFF2-40B4-BE49-F238E27FC236}">
-                <a16:creationId xmlns:a16="http://schemas.microsoft.com/office/drawing/2014/main" id="{42C732C2-91D3-AA31-1E74-5A70C1340EB5}"/>
-              </a:ext>
-            </a:extLst>
-          </p:cNvPr>
-          <p:cNvSpPr txBox="1"/>
-          <p:nvPr/>
-        </p:nvSpPr>
-        <p:spPr>
-          <a:xfrm>
-            <a:off x="215757" y="143840"/>
-            <a:ext cx="11784458" cy="6524863"/>
-          </a:xfrm>
-          <a:prstGeom prst="rect">
-            <a:avLst/>
-          </a:prstGeom>
-          <a:noFill/>
-        </p:spPr>
-        <p:txBody>
-          <a:bodyPr wrap="square" rtlCol="0">
-            <a:spAutoFit/>
-          </a:bodyPr>
-          <a:lstStyle/>
-          <a:p>
-            <a:pPr algn="just"/>
-            <a:r>
-              <a:rPr lang="en-US" sz="2200" dirty="0">
-                <a:latin typeface="Times New Roman" panose="02020603050405020304" pitchFamily="18" charset="0"/>
-                <a:cs typeface="Times New Roman" panose="02020603050405020304" pitchFamily="18" charset="0"/>
-              </a:rPr>
-              <a:t>You can reach out to me for any guidance, suggestions, or help regarding this system:</a:t>
-            </a:r>
-          </a:p>
-          <a:p>
-            <a:pPr algn="just"/>
-            <a:r>
-              <a:rPr lang="en-US" sz="2200" dirty="0">
-                <a:latin typeface="Times New Roman" panose="02020603050405020304" pitchFamily="18" charset="0"/>
-                <a:cs typeface="Times New Roman" panose="02020603050405020304" pitchFamily="18" charset="0"/>
-              </a:rPr>
-              <a:t>📧 </a:t>
-            </a:r>
-            <a:r>
-              <a:rPr lang="en-US" sz="2200" dirty="0">
-                <a:latin typeface="Times New Roman" panose="02020603050405020304" pitchFamily="18" charset="0"/>
-                <a:cs typeface="Times New Roman" panose="02020603050405020304" pitchFamily="18" charset="0"/>
-                <a:hlinkClick r:id="rId2"/>
-              </a:rPr>
-              <a:t>mailto:rawatmadhurima4@gmail.com</a:t>
-            </a:r>
-            <a:r>
-              <a:rPr lang="en-US" sz="2200" dirty="0">
-                <a:latin typeface="Times New Roman" panose="02020603050405020304" pitchFamily="18" charset="0"/>
-                <a:cs typeface="Times New Roman" panose="02020603050405020304" pitchFamily="18" charset="0"/>
-              </a:rPr>
-              <a:t>	🔗 </a:t>
-            </a:r>
-            <a:r>
-              <a:rPr lang="en-US" sz="2200" dirty="0">
-                <a:latin typeface="Times New Roman" panose="02020603050405020304" pitchFamily="18" charset="0"/>
-                <a:cs typeface="Times New Roman" panose="02020603050405020304" pitchFamily="18" charset="0"/>
-                <a:hlinkClick r:id="rId3"/>
-              </a:rPr>
-              <a:t>LinkedIn: Madhurima Rawat</a:t>
-            </a:r>
-            <a:endParaRPr lang="en-US" sz="2200" dirty="0">
-              <a:latin typeface="Times New Roman" panose="02020603050405020304" pitchFamily="18" charset="0"/>
-              <a:cs typeface="Times New Roman" panose="02020603050405020304" pitchFamily="18" charset="0"/>
-            </a:endParaRPr>
-          </a:p>
-          <a:p>
-            <a:pPr algn="just"/>
-            <a:endParaRPr lang="en-US" sz="2200" dirty="0">
-              <a:latin typeface="Times New Roman" panose="02020603050405020304" pitchFamily="18" charset="0"/>
-              <a:cs typeface="Times New Roman" panose="02020603050405020304" pitchFamily="18" charset="0"/>
-            </a:endParaRPr>
-          </a:p>
-          <a:p>
-            <a:pPr algn="just"/>
-            <a:r>
-              <a:rPr lang="en-US" sz="2200" dirty="0">
-                <a:latin typeface="Times New Roman" panose="02020603050405020304" pitchFamily="18" charset="0"/>
-                <a:cs typeface="Times New Roman" panose="02020603050405020304" pitchFamily="18" charset="0"/>
-              </a:rPr>
-              <a:t>If you’re looking for useful products, here are some recommendations:</a:t>
-            </a:r>
-          </a:p>
-          <a:p>
-            <a:pPr algn="just"/>
-            <a:endParaRPr lang="en-US" sz="2200" dirty="0">
-              <a:latin typeface="Times New Roman" panose="02020603050405020304" pitchFamily="18" charset="0"/>
-              <a:cs typeface="Times New Roman" panose="02020603050405020304" pitchFamily="18" charset="0"/>
-            </a:endParaRPr>
-          </a:p>
-          <a:p>
-            <a:pPr marL="342900" indent="-342900" algn="just">
-              <a:buFont typeface="+mj-lt"/>
-              <a:buAutoNum type="arabicPeriod"/>
-            </a:pPr>
-            <a:r>
-              <a:rPr lang="en-US" sz="2200" dirty="0">
-                <a:latin typeface="Times New Roman" panose="02020603050405020304" pitchFamily="18" charset="0"/>
-                <a:cs typeface="Times New Roman" panose="02020603050405020304" pitchFamily="18" charset="0"/>
-                <a:hlinkClick r:id="rId4"/>
-              </a:rPr>
-              <a:t>File with plastic sleeves </a:t>
-            </a:r>
-            <a:r>
-              <a:rPr lang="en-US" sz="2200" dirty="0">
-                <a:latin typeface="Times New Roman" panose="02020603050405020304" pitchFamily="18" charset="0"/>
-                <a:cs typeface="Times New Roman" panose="02020603050405020304" pitchFamily="18" charset="0"/>
-              </a:rPr>
-              <a:t>- best for storing original documents</a:t>
-            </a:r>
-          </a:p>
-          <a:p>
-            <a:pPr marL="342900" indent="-342900" algn="just">
-              <a:buFont typeface="+mj-lt"/>
-              <a:buAutoNum type="arabicPeriod"/>
-            </a:pPr>
-            <a:r>
-              <a:rPr lang="en-US" sz="2200" dirty="0">
-                <a:latin typeface="Times New Roman" panose="02020603050405020304" pitchFamily="18" charset="0"/>
-                <a:cs typeface="Times New Roman" panose="02020603050405020304" pitchFamily="18" charset="0"/>
-                <a:hlinkClick r:id="rId5"/>
-              </a:rPr>
-              <a:t>Card holder </a:t>
-            </a:r>
-            <a:r>
-              <a:rPr lang="en-US" sz="2200" dirty="0">
-                <a:latin typeface="Times New Roman" panose="02020603050405020304" pitchFamily="18" charset="0"/>
-                <a:cs typeface="Times New Roman" panose="02020603050405020304" pitchFamily="18" charset="0"/>
-              </a:rPr>
-              <a:t>-  very useful and handy for ID cards</a:t>
-            </a:r>
-          </a:p>
-          <a:p>
-            <a:pPr marL="342900" indent="-342900" algn="just">
-              <a:buFont typeface="+mj-lt"/>
-              <a:buAutoNum type="arabicPeriod"/>
-            </a:pPr>
-            <a:r>
-              <a:rPr lang="en-US" sz="2200" dirty="0">
-                <a:latin typeface="Times New Roman" panose="02020603050405020304" pitchFamily="18" charset="0"/>
-                <a:cs typeface="Times New Roman" panose="02020603050405020304" pitchFamily="18" charset="0"/>
-                <a:hlinkClick r:id="rId6"/>
-              </a:rPr>
-              <a:t>Clear bag / chic button folder </a:t>
-            </a:r>
-            <a:r>
-              <a:rPr lang="en-US" sz="2200" dirty="0">
-                <a:latin typeface="Times New Roman" panose="02020603050405020304" pitchFamily="18" charset="0"/>
-                <a:cs typeface="Times New Roman" panose="02020603050405020304" pitchFamily="18" charset="0"/>
-              </a:rPr>
-              <a:t>- for general document storage</a:t>
-            </a:r>
-          </a:p>
-          <a:p>
-            <a:pPr marL="342900" indent="-342900" algn="just">
-              <a:buFont typeface="+mj-lt"/>
-              <a:buAutoNum type="arabicPeriod"/>
-            </a:pPr>
-            <a:r>
-              <a:rPr lang="en-US" sz="2200" dirty="0">
-                <a:latin typeface="Times New Roman" panose="02020603050405020304" pitchFamily="18" charset="0"/>
-                <a:cs typeface="Times New Roman" panose="02020603050405020304" pitchFamily="18" charset="0"/>
-                <a:hlinkClick r:id="rId7"/>
-              </a:rPr>
-              <a:t>Clear zip folder</a:t>
-            </a:r>
-            <a:r>
-              <a:rPr lang="en-US" sz="2200" dirty="0">
-                <a:latin typeface="Times New Roman" panose="02020603050405020304" pitchFamily="18" charset="0"/>
-                <a:cs typeface="Times New Roman" panose="02020603050405020304" pitchFamily="18" charset="0"/>
-              </a:rPr>
-              <a:t> - secure and easy to carry</a:t>
-            </a:r>
-          </a:p>
-          <a:p>
-            <a:pPr marL="342900" indent="-342900" algn="just">
-              <a:buFont typeface="+mj-lt"/>
-              <a:buAutoNum type="arabicPeriod"/>
-            </a:pPr>
-            <a:r>
-              <a:rPr lang="en-US" sz="2200" dirty="0">
-                <a:latin typeface="Times New Roman" panose="02020603050405020304" pitchFamily="18" charset="0"/>
-                <a:cs typeface="Times New Roman" panose="02020603050405020304" pitchFamily="18" charset="0"/>
-                <a:hlinkClick r:id="rId8"/>
-              </a:rPr>
-              <a:t>Plastic expandable folder </a:t>
-            </a:r>
-            <a:r>
-              <a:rPr lang="en-US" sz="2200" dirty="0">
-                <a:latin typeface="Times New Roman" panose="02020603050405020304" pitchFamily="18" charset="0"/>
-                <a:cs typeface="Times New Roman" panose="02020603050405020304" pitchFamily="18" charset="0"/>
-              </a:rPr>
-              <a:t>- ideal for organizing multiple documents</a:t>
-            </a:r>
-          </a:p>
-          <a:p>
-            <a:pPr marL="342900" indent="-342900" algn="just">
-              <a:buFont typeface="+mj-lt"/>
-              <a:buAutoNum type="arabicPeriod"/>
-            </a:pPr>
-            <a:r>
-              <a:rPr lang="en-US" sz="2200" dirty="0">
-                <a:latin typeface="Times New Roman" panose="02020603050405020304" pitchFamily="18" charset="0"/>
-                <a:cs typeface="Times New Roman" panose="02020603050405020304" pitchFamily="18" charset="0"/>
-                <a:hlinkClick r:id="rId9"/>
-              </a:rPr>
-              <a:t>Plastic expandable professional folder </a:t>
-            </a:r>
-            <a:r>
-              <a:rPr lang="en-US" sz="2200" dirty="0">
-                <a:latin typeface="Times New Roman" panose="02020603050405020304" pitchFamily="18" charset="0"/>
-                <a:cs typeface="Times New Roman" panose="02020603050405020304" pitchFamily="18" charset="0"/>
-              </a:rPr>
-              <a:t>- suitable for office use</a:t>
-            </a:r>
-          </a:p>
-          <a:p>
-            <a:pPr algn="just"/>
-            <a:endParaRPr lang="en-US" sz="2200" dirty="0">
-              <a:latin typeface="Times New Roman" panose="02020603050405020304" pitchFamily="18" charset="0"/>
-              <a:cs typeface="Times New Roman" panose="02020603050405020304" pitchFamily="18" charset="0"/>
-            </a:endParaRPr>
-          </a:p>
-          <a:p>
-            <a:pPr algn="just"/>
-            <a:r>
-              <a:rPr lang="en-US" sz="2200" dirty="0">
-                <a:latin typeface="Times New Roman" panose="02020603050405020304" pitchFamily="18" charset="0"/>
-                <a:cs typeface="Times New Roman" panose="02020603050405020304" pitchFamily="18" charset="0"/>
-              </a:rPr>
-              <a:t>These product links are shared for general reference. You can check reviews before purchasing, or simply find similar options at your nearest stationery shop.</a:t>
-            </a:r>
-          </a:p>
-          <a:p>
-            <a:pPr algn="just"/>
-            <a:r>
-              <a:rPr lang="en-US" sz="2200" dirty="0">
-                <a:latin typeface="Times New Roman" panose="02020603050405020304" pitchFamily="18" charset="0"/>
-                <a:cs typeface="Times New Roman" panose="02020603050405020304" pitchFamily="18" charset="0"/>
-              </a:rPr>
-              <a:t>I have also included a slide containing the icons and labels as a separate PDF file, so it can be printed in high quality. I usually get all documents printed in PDF format, as it provides better clarity than image files. You can also convert it to any format of your choice directly from this PPT if needed.</a:t>
-            </a:r>
-          </a:p>
-          <a:p>
-            <a:pPr algn="just"/>
-            <a:r>
-              <a:rPr lang="en-US" sz="2200" b="1" dirty="0">
-                <a:latin typeface="Times New Roman" panose="02020603050405020304" pitchFamily="18" charset="0"/>
-                <a:cs typeface="Times New Roman" panose="02020603050405020304" pitchFamily="18" charset="0"/>
-              </a:rPr>
-              <a:t>If this helped you, do drop a ⭐ on my repository </a:t>
-            </a:r>
-            <a:r>
-              <a:rPr lang="en-IN" sz="2200" dirty="0">
-                <a:latin typeface="Times New Roman" panose="02020603050405020304" pitchFamily="18" charset="0"/>
-                <a:cs typeface="Times New Roman" panose="02020603050405020304" pitchFamily="18" charset="0"/>
-                <a:hlinkClick r:id="rId10"/>
-              </a:rPr>
-              <a:t>https://github.com/madhurimarawat/Essential-Templates-Kit</a:t>
-            </a:r>
-            <a:r>
-              <a:rPr lang="en-US" sz="2200" b="1" dirty="0">
-                <a:latin typeface="Times New Roman" panose="02020603050405020304" pitchFamily="18" charset="0"/>
-                <a:cs typeface="Times New Roman" panose="02020603050405020304" pitchFamily="18" charset="0"/>
-              </a:rPr>
-              <a:t>, it would mean a lot! </a:t>
-            </a:r>
-            <a:endParaRPr lang="en-US" sz="2200" dirty="0">
-              <a:latin typeface="Times New Roman" panose="02020603050405020304" pitchFamily="18" charset="0"/>
-              <a:cs typeface="Times New Roman" panose="02020603050405020304" pitchFamily="18" charset="0"/>
-            </a:endParaRPr>
-          </a:p>
-        </p:txBody>
-      </p:sp>
-    </p:spTree>
-    <p:extLst>
-      <p:ext uri="{BB962C8B-B14F-4D97-AF65-F5344CB8AC3E}">
-        <p14:creationId xmlns:p14="http://schemas.microsoft.com/office/powerpoint/2010/main" val="3054229722"/>
       </p:ext>
     </p:extLst>
   </p:cSld>

</xml_diff>

<commit_message>
Add Color coding details
</commit_message>
<xml_diff>
--- a/Document_Organization/Document_Folder_Formatting.pptx
+++ b/Document_Organization/Document_Folder_Formatting.pptx
@@ -5,7 +5,7 @@
     <p:sldMasterId id="2147483648" r:id="rId1"/>
   </p:sldMasterIdLst>
   <p:notesMasterIdLst>
-    <p:notesMasterId r:id="rId12"/>
+    <p:notesMasterId r:id="rId13"/>
   </p:notesMasterIdLst>
   <p:sldIdLst>
     <p:sldId id="257" r:id="rId2"/>
@@ -16,8 +16,9 @@
     <p:sldId id="261" r:id="rId7"/>
     <p:sldId id="264" r:id="rId8"/>
     <p:sldId id="265" r:id="rId9"/>
-    <p:sldId id="260" r:id="rId10"/>
-    <p:sldId id="259" r:id="rId11"/>
+    <p:sldId id="266" r:id="rId10"/>
+    <p:sldId id="260" r:id="rId11"/>
+    <p:sldId id="259" r:id="rId12"/>
   </p:sldIdLst>
   <p:sldSz cx="12192000" cy="6858000"/>
   <p:notesSz cx="6858000" cy="9144000"/>
@@ -3125,7 +3126,7 @@
           <a:p>
             <a:fld id="{B8F0210C-1BDD-4952-85C7-BA7C0230B72A}" type="datetimeFigureOut">
               <a:rPr lang="en-IN" smtClean="0"/>
-              <a:t>02-04-2026</a:t>
+              <a:t>11-04-2026</a:t>
             </a:fld>
             <a:endParaRPr lang="en-IN"/>
           </a:p>
@@ -3629,7 +3630,7 @@
           <a:p>
             <a:fld id="{A544FFC6-13CD-4522-9B98-D20659D3626D}" type="datetimeFigureOut">
               <a:rPr lang="en-IN" smtClean="0"/>
-              <a:t>02-04-2026</a:t>
+              <a:t>11-04-2026</a:t>
             </a:fld>
             <a:endParaRPr lang="en-IN"/>
           </a:p>
@@ -3829,7 +3830,7 @@
           <a:p>
             <a:fld id="{A544FFC6-13CD-4522-9B98-D20659D3626D}" type="datetimeFigureOut">
               <a:rPr lang="en-IN" smtClean="0"/>
-              <a:t>02-04-2026</a:t>
+              <a:t>11-04-2026</a:t>
             </a:fld>
             <a:endParaRPr lang="en-IN"/>
           </a:p>
@@ -4039,7 +4040,7 @@
           <a:p>
             <a:fld id="{A544FFC6-13CD-4522-9B98-D20659D3626D}" type="datetimeFigureOut">
               <a:rPr lang="en-IN" smtClean="0"/>
-              <a:t>02-04-2026</a:t>
+              <a:t>11-04-2026</a:t>
             </a:fld>
             <a:endParaRPr lang="en-IN"/>
           </a:p>
@@ -4239,7 +4240,7 @@
           <a:p>
             <a:fld id="{A544FFC6-13CD-4522-9B98-D20659D3626D}" type="datetimeFigureOut">
               <a:rPr lang="en-IN" smtClean="0"/>
-              <a:t>02-04-2026</a:t>
+              <a:t>11-04-2026</a:t>
             </a:fld>
             <a:endParaRPr lang="en-IN"/>
           </a:p>
@@ -4515,7 +4516,7 @@
           <a:p>
             <a:fld id="{A544FFC6-13CD-4522-9B98-D20659D3626D}" type="datetimeFigureOut">
               <a:rPr lang="en-IN" smtClean="0"/>
-              <a:t>02-04-2026</a:t>
+              <a:t>11-04-2026</a:t>
             </a:fld>
             <a:endParaRPr lang="en-IN"/>
           </a:p>
@@ -4783,7 +4784,7 @@
           <a:p>
             <a:fld id="{A544FFC6-13CD-4522-9B98-D20659D3626D}" type="datetimeFigureOut">
               <a:rPr lang="en-IN" smtClean="0"/>
-              <a:t>02-04-2026</a:t>
+              <a:t>11-04-2026</a:t>
             </a:fld>
             <a:endParaRPr lang="en-IN"/>
           </a:p>
@@ -5198,7 +5199,7 @@
           <a:p>
             <a:fld id="{A544FFC6-13CD-4522-9B98-D20659D3626D}" type="datetimeFigureOut">
               <a:rPr lang="en-IN" smtClean="0"/>
-              <a:t>02-04-2026</a:t>
+              <a:t>11-04-2026</a:t>
             </a:fld>
             <a:endParaRPr lang="en-IN"/>
           </a:p>
@@ -5340,7 +5341,7 @@
           <a:p>
             <a:fld id="{A544FFC6-13CD-4522-9B98-D20659D3626D}" type="datetimeFigureOut">
               <a:rPr lang="en-IN" smtClean="0"/>
-              <a:t>02-04-2026</a:t>
+              <a:t>11-04-2026</a:t>
             </a:fld>
             <a:endParaRPr lang="en-IN"/>
           </a:p>
@@ -5453,7 +5454,7 @@
           <a:p>
             <a:fld id="{A544FFC6-13CD-4522-9B98-D20659D3626D}" type="datetimeFigureOut">
               <a:rPr lang="en-IN" smtClean="0"/>
-              <a:t>02-04-2026</a:t>
+              <a:t>11-04-2026</a:t>
             </a:fld>
             <a:endParaRPr lang="en-IN"/>
           </a:p>
@@ -5766,7 +5767,7 @@
           <a:p>
             <a:fld id="{A544FFC6-13CD-4522-9B98-D20659D3626D}" type="datetimeFigureOut">
               <a:rPr lang="en-IN" smtClean="0"/>
-              <a:t>02-04-2026</a:t>
+              <a:t>11-04-2026</a:t>
             </a:fld>
             <a:endParaRPr lang="en-IN"/>
           </a:p>
@@ -6055,7 +6056,7 @@
           <a:p>
             <a:fld id="{A544FFC6-13CD-4522-9B98-D20659D3626D}" type="datetimeFigureOut">
               <a:rPr lang="en-IN" smtClean="0"/>
-              <a:t>02-04-2026</a:t>
+              <a:t>11-04-2026</a:t>
             </a:fld>
             <a:endParaRPr lang="en-IN"/>
           </a:p>
@@ -6298,7 +6299,7 @@
           <a:p>
             <a:fld id="{A544FFC6-13CD-4522-9B98-D20659D3626D}" type="datetimeFigureOut">
               <a:rPr lang="en-IN" smtClean="0"/>
-              <a:t>02-04-2026</a:t>
+              <a:t>11-04-2026</a:t>
             </a:fld>
             <a:endParaRPr lang="en-IN"/>
           </a:p>
@@ -6852,6 +6853,107 @@
   <p:cSld>
     <p:spTree>
       <p:nvGrpSpPr>
+        <p:cNvPr id="1" name="">
+          <a:extLst>
+            <a:ext uri="{FF2B5EF4-FFF2-40B4-BE49-F238E27FC236}">
+              <a16:creationId xmlns:a16="http://schemas.microsoft.com/office/drawing/2014/main" id="{B6515905-71A1-3399-4245-7C8E9041D044}"/>
+            </a:ext>
+          </a:extLst>
+        </p:cNvPr>
+        <p:cNvGrpSpPr/>
+        <p:nvPr/>
+      </p:nvGrpSpPr>
+      <p:grpSpPr>
+        <a:xfrm>
+          <a:off x="0" y="0"/>
+          <a:ext cx="0" cy="0"/>
+          <a:chOff x="0" y="0"/>
+          <a:chExt cx="0" cy="0"/>
+        </a:xfrm>
+      </p:grpSpPr>
+      <p:sp>
+        <p:nvSpPr>
+          <p:cNvPr id="2" name="Title 1">
+            <a:extLst>
+              <a:ext uri="{FF2B5EF4-FFF2-40B4-BE49-F238E27FC236}">
+                <a16:creationId xmlns:a16="http://schemas.microsoft.com/office/drawing/2014/main" id="{2B2E2663-AF8B-A5B0-3240-777192B80011}"/>
+              </a:ext>
+            </a:extLst>
+          </p:cNvPr>
+          <p:cNvSpPr>
+            <a:spLocks noGrp="1"/>
+          </p:cNvSpPr>
+          <p:nvPr>
+            <p:ph type="title"/>
+          </p:nvPr>
+        </p:nvSpPr>
+        <p:spPr>
+          <a:xfrm>
+            <a:off x="848475" y="-148583"/>
+            <a:ext cx="10515600" cy="1325563"/>
+          </a:xfrm>
+        </p:spPr>
+        <p:txBody>
+          <a:bodyPr/>
+          <a:lstStyle/>
+          <a:p>
+            <a:pPr algn="ctr"/>
+            <a:r>
+              <a:rPr lang="en-IN" b="1" dirty="0"/>
+              <a:t>Original Document Organization</a:t>
+            </a:r>
+          </a:p>
+        </p:txBody>
+      </p:sp>
+      <p:graphicFrame>
+        <p:nvGraphicFramePr>
+          <p:cNvPr id="4" name="Content Placeholder 3">
+            <a:extLst>
+              <a:ext uri="{FF2B5EF4-FFF2-40B4-BE49-F238E27FC236}">
+                <a16:creationId xmlns:a16="http://schemas.microsoft.com/office/drawing/2014/main" id="{7813A196-3082-0688-B4E9-00E6FFB3F3B6}"/>
+              </a:ext>
+            </a:extLst>
+          </p:cNvPr>
+          <p:cNvGraphicFramePr>
+            <a:graphicFrameLocks noGrp="1"/>
+          </p:cNvGraphicFramePr>
+          <p:nvPr>
+            <p:ph idx="1"/>
+            <p:extLst>
+              <p:ext uri="{D42A27DB-BD31-4B8C-83A1-F6EECF244321}">
+                <p14:modId xmlns:p14="http://schemas.microsoft.com/office/powerpoint/2010/main" val="600299107"/>
+              </p:ext>
+            </p:extLst>
+          </p:nvPr>
+        </p:nvGraphicFramePr>
+        <p:xfrm>
+          <a:off x="215757" y="1130157"/>
+          <a:ext cx="11702265" cy="5578868"/>
+        </p:xfrm>
+        <a:graphic>
+          <a:graphicData uri="http://schemas.openxmlformats.org/drawingml/2006/diagram">
+            <dgm:relIds xmlns:dgm="http://schemas.openxmlformats.org/drawingml/2006/diagram" xmlns:r="http://schemas.openxmlformats.org/officeDocument/2006/relationships" r:dm="rId2" r:lo="rId3" r:qs="rId4" r:cs="rId5"/>
+          </a:graphicData>
+        </a:graphic>
+      </p:graphicFrame>
+    </p:spTree>
+    <p:extLst>
+      <p:ext uri="{BB962C8B-B14F-4D97-AF65-F5344CB8AC3E}">
+        <p14:creationId xmlns:p14="http://schemas.microsoft.com/office/powerpoint/2010/main" val="4260442206"/>
+      </p:ext>
+    </p:extLst>
+  </p:cSld>
+  <p:clrMapOvr>
+    <a:masterClrMapping/>
+  </p:clrMapOvr>
+</p:sld>
+</file>
+
+<file path=ppt/slides/slide11.xml><?xml version="1.0" encoding="utf-8"?>
+<p:sld xmlns:a="http://schemas.openxmlformats.org/drawingml/2006/main" xmlns:r="http://schemas.openxmlformats.org/officeDocument/2006/relationships" xmlns:p="http://schemas.openxmlformats.org/presentationml/2006/main">
+  <p:cSld>
+    <p:spTree>
+      <p:nvGrpSpPr>
         <p:cNvPr id="1" name=""/>
         <p:cNvGrpSpPr/>
         <p:nvPr/>
@@ -10145,7 +10247,7 @@
         <p:cNvPr id="1" name="">
           <a:extLst>
             <a:ext uri="{FF2B5EF4-FFF2-40B4-BE49-F238E27FC236}">
-              <a16:creationId xmlns:a16="http://schemas.microsoft.com/office/drawing/2014/main" id="{B6515905-71A1-3399-4245-7C8E9041D044}"/>
+              <a16:creationId xmlns:a16="http://schemas.microsoft.com/office/drawing/2014/main" id="{5E5313BA-CEA4-E6C8-B221-3D91ECF54893}"/>
             </a:ext>
           </a:extLst>
         </p:cNvPr>
@@ -10165,7 +10267,7 @@
           <p:cNvPr id="2" name="Title 1">
             <a:extLst>
               <a:ext uri="{FF2B5EF4-FFF2-40B4-BE49-F238E27FC236}">
-                <a16:creationId xmlns:a16="http://schemas.microsoft.com/office/drawing/2014/main" id="{2B2E2663-AF8B-A5B0-3240-777192B80011}"/>
+                <a16:creationId xmlns:a16="http://schemas.microsoft.com/office/drawing/2014/main" id="{471B8234-9B62-2372-5BAB-3864FBF79C5F}"/>
               </a:ext>
             </a:extLst>
           </p:cNvPr>
@@ -10189,46 +10291,243 @@
             <a:pPr algn="ctr"/>
             <a:r>
               <a:rPr lang="en-IN" b="1" dirty="0"/>
-              <a:t>Original Document Organization</a:t>
+              <a:t>Colour Coding in a Single Folder</a:t>
             </a:r>
           </a:p>
         </p:txBody>
       </p:sp>
-      <p:graphicFrame>
-        <p:nvGraphicFramePr>
-          <p:cNvPr id="4" name="Content Placeholder 3">
-            <a:extLst>
-              <a:ext uri="{FF2B5EF4-FFF2-40B4-BE49-F238E27FC236}">
-                <a16:creationId xmlns:a16="http://schemas.microsoft.com/office/drawing/2014/main" id="{7813A196-3082-0688-B4E9-00E6FFB3F3B6}"/>
-              </a:ext>
-            </a:extLst>
-          </p:cNvPr>
-          <p:cNvGraphicFramePr>
-            <a:graphicFrameLocks noGrp="1"/>
-          </p:cNvGraphicFramePr>
+      <p:sp>
+        <p:nvSpPr>
+          <p:cNvPr id="4" name="Rectangle 2">
+            <a:extLst>
+              <a:ext uri="{FF2B5EF4-FFF2-40B4-BE49-F238E27FC236}">
+                <a16:creationId xmlns:a16="http://schemas.microsoft.com/office/drawing/2014/main" id="{98A3DD00-4504-820D-E351-1F8147C7A2E3}"/>
+              </a:ext>
+            </a:extLst>
+          </p:cNvPr>
+          <p:cNvSpPr>
+            <a:spLocks noGrp="1" noChangeArrowheads="1"/>
+          </p:cNvSpPr>
           <p:nvPr>
             <p:ph idx="1"/>
-            <p:extLst>
-              <p:ext uri="{D42A27DB-BD31-4B8C-83A1-F6EECF244321}">
-                <p14:modId xmlns:p14="http://schemas.microsoft.com/office/powerpoint/2010/main" val="600299107"/>
-              </p:ext>
-            </p:extLst>
           </p:nvPr>
-        </p:nvGraphicFramePr>
-        <p:xfrm>
-          <a:off x="215757" y="1130157"/>
-          <a:ext cx="11702265" cy="5578868"/>
-        </p:xfrm>
-        <a:graphic>
-          <a:graphicData uri="http://schemas.openxmlformats.org/drawingml/2006/diagram">
-            <dgm:relIds xmlns:dgm="http://schemas.openxmlformats.org/drawingml/2006/diagram" xmlns:r="http://schemas.openxmlformats.org/officeDocument/2006/relationships" r:dm="rId2" r:lo="rId3" r:qs="rId4" r:cs="rId5"/>
-          </a:graphicData>
-        </a:graphic>
-      </p:graphicFrame>
+        </p:nvSpPr>
+        <p:spPr bwMode="auto">
+          <a:xfrm>
+            <a:off x="233916" y="935166"/>
+            <a:ext cx="11797122" cy="5693866"/>
+          </a:xfrm>
+          <a:prstGeom prst="rect">
+            <a:avLst/>
+          </a:prstGeom>
+          <a:noFill/>
+          <a:ln>
+            <a:noFill/>
+          </a:ln>
+          <a:effectLst/>
+          <a:extLst>
+            <a:ext uri="{909E8E84-426E-40DD-AFC4-6F175D3DCCD1}">
+              <a14:hiddenFill xmlns:a14="http://schemas.microsoft.com/office/drawing/2010/main">
+                <a:solidFill>
+                  <a:schemeClr val="accent1"/>
+                </a:solidFill>
+              </a14:hiddenFill>
+            </a:ext>
+            <a:ext uri="{91240B29-F687-4F45-9708-019B960494DF}">
+              <a14:hiddenLine xmlns:a14="http://schemas.microsoft.com/office/drawing/2010/main" w="9525">
+                <a:solidFill>
+                  <a:schemeClr val="tx1"/>
+                </a:solidFill>
+                <a:miter lim="800000"/>
+                <a:headEnd/>
+                <a:tailEnd/>
+              </a14:hiddenLine>
+            </a:ext>
+            <a:ext uri="{AF507438-7753-43E0-B8FC-AC1667EBCBE1}">
+              <a14:hiddenEffects xmlns:a14="http://schemas.microsoft.com/office/drawing/2010/main">
+                <a:effectLst>
+                  <a:outerShdw dist="35921" dir="2700000" algn="ctr" rotWithShape="0">
+                    <a:schemeClr val="bg2"/>
+                  </a:outerShdw>
+                </a:effectLst>
+              </a14:hiddenEffects>
+            </a:ext>
+          </a:extLst>
+        </p:spPr>
+        <p:txBody>
+          <a:bodyPr vert="horz" wrap="square" lIns="91440" tIns="45720" rIns="91440" bIns="45720" numCol="1" anchor="ctr" anchorCtr="0" compatLnSpc="1">
+            <a:prstTxWarp prst="textNoShape">
+              <a:avLst/>
+            </a:prstTxWarp>
+            <a:spAutoFit/>
+          </a:bodyPr>
+          <a:lstStyle/>
+          <a:p>
+            <a:pPr algn="just" eaLnBrk="0" fontAlgn="base" hangingPunct="0">
+              <a:lnSpc>
+                <a:spcPct val="100000"/>
+              </a:lnSpc>
+              <a:spcBef>
+                <a:spcPct val="0"/>
+              </a:spcBef>
+              <a:spcAft>
+                <a:spcPct val="0"/>
+              </a:spcAft>
+            </a:pPr>
+            <a:r>
+              <a:rPr lang="en-US" sz="2600" dirty="0">
+                <a:latin typeface="Constantia" panose="02030602050306030303" pitchFamily="18" charset="0"/>
+              </a:rPr>
+              <a:t>Organize your folder by assigning colors to categories, for example red for identity documents and blue for medical records.</a:t>
+            </a:r>
+          </a:p>
+          <a:p>
+            <a:pPr algn="just" eaLnBrk="0" fontAlgn="base" hangingPunct="0">
+              <a:lnSpc>
+                <a:spcPct val="100000"/>
+              </a:lnSpc>
+              <a:spcBef>
+                <a:spcPct val="0"/>
+              </a:spcBef>
+              <a:spcAft>
+                <a:spcPct val="0"/>
+              </a:spcAft>
+            </a:pPr>
+            <a:r>
+              <a:rPr lang="en-US" sz="2600" dirty="0">
+                <a:latin typeface="Constantia" panose="02030602050306030303" pitchFamily="18" charset="0"/>
+              </a:rPr>
+              <a:t>Create a personal master index page and list all categories with their color labels.</a:t>
+            </a:r>
+          </a:p>
+          <a:p>
+            <a:pPr algn="just" eaLnBrk="0" fontAlgn="base" hangingPunct="0">
+              <a:lnSpc>
+                <a:spcPct val="100000"/>
+              </a:lnSpc>
+              <a:spcBef>
+                <a:spcPct val="0"/>
+              </a:spcBef>
+              <a:spcAft>
+                <a:spcPct val="0"/>
+              </a:spcAft>
+            </a:pPr>
+            <a:r>
+              <a:rPr lang="en-US" sz="2600" dirty="0">
+                <a:latin typeface="Constantia" panose="02030602050306030303" pitchFamily="18" charset="0"/>
+              </a:rPr>
+              <a:t>If you want subcategories like school IDs or college IDs, create a new index page in the same color (e.g., red) and label it as an index.</a:t>
+            </a:r>
+          </a:p>
+          <a:p>
+            <a:pPr algn="just" eaLnBrk="0" fontAlgn="base" hangingPunct="0">
+              <a:lnSpc>
+                <a:spcPct val="100000"/>
+              </a:lnSpc>
+              <a:spcBef>
+                <a:spcPct val="0"/>
+              </a:spcBef>
+              <a:spcAft>
+                <a:spcPct val="0"/>
+              </a:spcAft>
+            </a:pPr>
+            <a:r>
+              <a:rPr lang="en-US" sz="2600" dirty="0">
+                <a:latin typeface="Constantia" panose="02030602050306030303" pitchFamily="18" charset="0"/>
+              </a:rPr>
+              <a:t>Keep the label placement and style consistent with the main category for clarity.</a:t>
+            </a:r>
+          </a:p>
+          <a:p>
+            <a:pPr algn="just" eaLnBrk="0" fontAlgn="base" hangingPunct="0">
+              <a:lnSpc>
+                <a:spcPct val="100000"/>
+              </a:lnSpc>
+              <a:spcBef>
+                <a:spcPct val="0"/>
+              </a:spcBef>
+              <a:spcAft>
+                <a:spcPct val="0"/>
+              </a:spcAft>
+            </a:pPr>
+            <a:r>
+              <a:rPr lang="en-US" sz="2600" dirty="0">
+                <a:latin typeface="Constantia" panose="02030602050306030303" pitchFamily="18" charset="0"/>
+              </a:rPr>
+              <a:t>This system helps you expand categories easily while keeping everything organized.</a:t>
+            </a:r>
+          </a:p>
+          <a:p>
+            <a:pPr algn="just" eaLnBrk="0" fontAlgn="base" hangingPunct="0">
+              <a:lnSpc>
+                <a:spcPct val="100000"/>
+              </a:lnSpc>
+              <a:spcBef>
+                <a:spcPct val="0"/>
+              </a:spcBef>
+              <a:spcAft>
+                <a:spcPct val="0"/>
+              </a:spcAft>
+            </a:pPr>
+            <a:r>
+              <a:rPr lang="en-US" sz="2600" dirty="0">
+                <a:latin typeface="Constantia" panose="02030602050306030303" pitchFamily="18" charset="0"/>
+              </a:rPr>
+              <a:t>The advantage is that once you see a color, you instantly recognize the category, like red for identity.</a:t>
+            </a:r>
+          </a:p>
+          <a:p>
+            <a:pPr algn="just" eaLnBrk="0" fontAlgn="base" hangingPunct="0">
+              <a:lnSpc>
+                <a:spcPct val="100000"/>
+              </a:lnSpc>
+              <a:spcBef>
+                <a:spcPct val="0"/>
+              </a:spcBef>
+              <a:spcAft>
+                <a:spcPct val="0"/>
+              </a:spcAft>
+            </a:pPr>
+            <a:r>
+              <a:rPr lang="en-US" sz="2600" dirty="0">
+                <a:latin typeface="Constantia" panose="02030602050306030303" pitchFamily="18" charset="0"/>
+              </a:rPr>
+              <a:t>You can also include this information in both the outer index and the master index if needed.</a:t>
+            </a:r>
+            <a:endParaRPr lang="en-IN" sz="2600" dirty="0">
+              <a:latin typeface="Constantia" panose="02030602050306030303" pitchFamily="18" charset="0"/>
+            </a:endParaRPr>
+          </a:p>
+          <a:p>
+            <a:pPr marL="0" indent="0" algn="just" eaLnBrk="0" fontAlgn="base" hangingPunct="0">
+              <a:lnSpc>
+                <a:spcPct val="100000"/>
+              </a:lnSpc>
+              <a:spcBef>
+                <a:spcPct val="0"/>
+              </a:spcBef>
+              <a:spcAft>
+                <a:spcPct val="0"/>
+              </a:spcAft>
+              <a:buNone/>
+            </a:pPr>
+            <a:r>
+              <a:rPr lang="en-IN" sz="2600" b="1" dirty="0">
+                <a:latin typeface="Constantia" panose="02030602050306030303" pitchFamily="18" charset="0"/>
+              </a:rPr>
+              <a:t>Index Page → Documents → Subcategory Index Page → Sub Category Documents → Next Index Page → Documents ...</a:t>
+            </a:r>
+            <a:endParaRPr lang="en-US" sz="2600" dirty="0">
+              <a:latin typeface="Times New Roman" panose="02020603050405020304" pitchFamily="18" charset="0"/>
+              <a:cs typeface="Times New Roman" panose="02020603050405020304" pitchFamily="18" charset="0"/>
+            </a:endParaRPr>
+          </a:p>
+        </p:txBody>
+      </p:sp>
     </p:spTree>
     <p:extLst>
       <p:ext uri="{BB962C8B-B14F-4D97-AF65-F5344CB8AC3E}">
-        <p14:creationId xmlns:p14="http://schemas.microsoft.com/office/powerpoint/2010/main" val="4260442206"/>
+        <p14:creationId xmlns:p14="http://schemas.microsoft.com/office/powerpoint/2010/main" val="3285681506"/>
       </p:ext>
     </p:extLst>
   </p:cSld>

</xml_diff>